<commit_message>
Strengthen final submission visuals
</commit_message>
<xml_diff>
--- a/artifacts/submission/disburseguard-slides.pptx
+++ b/artifacts/submission/disburseguard-slides.pptx
@@ -11,9 +11,10 @@
     <p:sldId id="259" r:id="rId5"/>
     <p:sldId id="260" r:id="rId6"/>
     <p:sldId id="261" r:id="rId7"/>
+    <p:sldId id="262" r:id="rId8"/>
   </p:sldIdLst>
   <p:notesMasterIdLst>
-    <p:notesMasterId r:id="rId8"/>
+    <p:notesMasterId r:id="rId9"/>
   </p:notesMasterIdLst>
   <p:sldSz cx="12192000" cy="6858000"/>
   <p:notesSz cx="6858000" cy="12192000"/>
@@ -971,6 +972,94 @@
             <a:fld id="{F7021451-1387-4CA6-816F-3879F97B5CBC}" type="slidenum">
               <a:rPr lang="en-US"/>
               <a:t>6</a:t>
+            </a:fld>
+            <a:endParaRPr lang="en-US"/>
+          </a:p>
+        </p:txBody>
+      </p:sp>
+    </p:spTree>
+    <p:extLst>
+      <p:ext uri="{BB962C8B-B14F-4D97-AF65-F5344CB8AC3E}">
+        <p14:creationId xmlns:p14="http://schemas.microsoft.com/office/powerpoint/2010/main" val="1024086991"/>
+      </p:ext>
+    </p:extLst>
+  </p:cSld>
+  <p:clrMapOvr>
+    <a:masterClrMapping/>
+  </p:clrMapOvr>
+</p:notes>
+</file>
+
+<file path=ppt/notesSlides/notesSlide7.xml><?xml version="1.0" encoding="utf-8"?>
+<p:notes xmlns:a="http://schemas.openxmlformats.org/drawingml/2006/main" xmlns:r="http://schemas.openxmlformats.org/officeDocument/2006/relationships" xmlns:p="http://schemas.openxmlformats.org/presentationml/2006/main">
+  <p:cSld>
+    <p:spTree>
+      <p:nvGrpSpPr>
+        <p:cNvPr id="1" name=""/>
+        <p:cNvGrpSpPr/>
+        <p:nvPr/>
+      </p:nvGrpSpPr>
+      <p:grpSpPr>
+        <a:xfrm>
+          <a:off x="0" y="0"/>
+          <a:ext cx="0" cy="0"/>
+          <a:chOff x="0" y="0"/>
+          <a:chExt cx="0" cy="0"/>
+        </a:xfrm>
+      </p:grpSpPr>
+      <p:sp>
+        <p:nvSpPr>
+          <p:cNvPr id="2" name="Slide Image Placeholder 1"/>
+          <p:cNvSpPr>
+            <a:spLocks noGrp="1" noRot="1" noChangeAspect="1"/>
+          </p:cNvSpPr>
+          <p:nvPr>
+            <p:ph type="sldImg"/>
+          </p:nvPr>
+        </p:nvSpPr>
+        <p:spPr/>
+      </p:sp>
+      <p:sp>
+        <p:nvSpPr>
+          <p:cNvPr id="3" name="Notes Placeholder 2"/>
+          <p:cNvSpPr>
+            <a:spLocks noGrp="1"/>
+          </p:cNvSpPr>
+          <p:nvPr>
+            <p:ph type="body" idx="1"/>
+          </p:nvPr>
+        </p:nvSpPr>
+        <p:spPr/>
+        <p:txBody>
+          <a:bodyPr/>
+          <a:lstStyle/>
+          <a:p>
+            <a:r>
+              <a:rPr lang="en-US" dirty="0"/>
+              <a:t/>
+            </a:r>
+            <a:endParaRPr lang="en-US" dirty="0"/>
+          </a:p>
+        </p:txBody>
+      </p:sp>
+      <p:sp>
+        <p:nvSpPr>
+          <p:cNvPr id="4" name="Slide Number Placeholder 3"/>
+          <p:cNvSpPr>
+            <a:spLocks noGrp="1"/>
+          </p:cNvSpPr>
+          <p:nvPr>
+            <p:ph type="sldNum" sz="quarter" idx="10"/>
+          </p:nvPr>
+        </p:nvSpPr>
+        <p:spPr/>
+        <p:txBody>
+          <a:bodyPr/>
+          <a:lstStyle/>
+          <a:p>
+            <a:fld id="{F7021451-1387-4CA6-816F-3879F97B5CBC}" type="slidenum">
+              <a:rPr lang="en-US"/>
+              <a:t>7</a:t>
             </a:fld>
             <a:endParaRPr lang="en-US"/>
           </a:p>
@@ -1302,7 +1391,7 @@
     <p:bg>
       <p:bgPr>
         <a:solidFill>
-          <a:srgbClr val="10110F"/>
+          <a:srgbClr val="0B0C0A"/>
         </a:solidFill>
       </p:bgPr>
     </p:bg>
@@ -1328,18 +1417,18 @@
         </p:nvSpPr>
         <p:spPr>
           <a:xfrm>
-            <a:off x="320040" y="320040"/>
-            <a:ext cx="11548872" cy="6217920"/>
+            <a:off x="256032" y="256032"/>
+            <a:ext cx="11686032" cy="6355080"/>
           </a:xfrm>
           <a:prstGeom prst="rect">
             <a:avLst/>
           </a:prstGeom>
           <a:solidFill>
-            <a:srgbClr val="191B17"/>
+            <a:srgbClr val="12140F"/>
           </a:solidFill>
           <a:ln w="12700">
             <a:solidFill>
-              <a:srgbClr val="393A31"/>
+              <a:srgbClr val="3A3D32"/>
             </a:solidFill>
             <a:prstDash val="solid"/>
           </a:ln>
@@ -1353,8 +1442,8 @@
         </p:nvSpPr>
         <p:spPr>
           <a:xfrm>
-            <a:off x="594360" y="640080"/>
-            <a:ext cx="3108960" cy="228600"/>
+            <a:off x="566928" y="621792"/>
+            <a:ext cx="2926080" cy="237744"/>
           </a:xfrm>
           <a:prstGeom prst="rect">
             <a:avLst/>
@@ -1375,7 +1464,7 @@
                   <a:srgbClr val="C9B98B"/>
                 </a:solidFill>
               </a:rPr>
-              <a:t>DISBURSEGUARD</a:t>
+              <a:t>01 / THESIS</a:t>
             </a:r>
             <a:endParaRPr lang="en-US" sz="1000" dirty="0"/>
           </a:p>
@@ -1389,8 +1478,8 @@
         </p:nvSpPr>
         <p:spPr>
           <a:xfrm>
-            <a:off x="594360" y="1005840"/>
-            <a:ext cx="6537960" cy="1188720"/>
+            <a:off x="566928" y="960120"/>
+            <a:ext cx="6080760" cy="1508760"/>
           </a:xfrm>
           <a:prstGeom prst="rect">
             <a:avLst/>
@@ -1408,14 +1497,14 @@
               <a:buNone/>
             </a:pPr>
             <a:r>
-              <a:rPr lang="en-US" sz="3600" b="1" dirty="0">
-                <a:solidFill>
-                  <a:srgbClr val="F4F1E9"/>
-                </a:solidFill>
-              </a:rPr>
-              <a:t>Proof-Paid Treasury Firewall</a:t>
-            </a:r>
-            <a:endParaRPr lang="en-US" sz="3600" dirty="0"/>
+              <a:rPr lang="en-US" sz="3800" b="1" dirty="0">
+                <a:solidFill>
+                  <a:srgbClr val="F7F3E8"/>
+                </a:solidFill>
+              </a:rPr>
+              <a:t>No proof. No payout.</a:t>
+            </a:r>
+            <a:endParaRPr lang="en-US" sz="3800" dirty="0"/>
           </a:p>
         </p:txBody>
       </p:sp>
@@ -1427,8 +1516,8 @@
         </p:nvSpPr>
         <p:spPr>
           <a:xfrm>
-            <a:off x="621792" y="2423160"/>
-            <a:ext cx="5989320" cy="1280160"/>
+            <a:off x="594360" y="2615184"/>
+            <a:ext cx="5650992" cy="1097280"/>
           </a:xfrm>
           <a:prstGeom prst="rect">
             <a:avLst/>
@@ -1446,14 +1535,14 @@
               <a:buNone/>
             </a:pPr>
             <a:r>
-              <a:rPr lang="en-US" sz="1600" dirty="0">
+              <a:rPr lang="en-US" sz="1500" dirty="0">
                 <a:solidFill>
                   <a:srgbClr val="AAA79D"/>
                 </a:solidFill>
               </a:rPr>
-              <a:t>No proof, no payout. AI payout agents must buy, verify, sign, and ledger proof before company money can move.</a:t>
-            </a:r>
-            <a:endParaRPr lang="en-US" sz="1600" dirty="0"/>
+              <a:t>DisburseGuard is a proof-paid treasury firewall for AI payout agents. The agent must buy, verify, sign, and ledger proof before company money can move.</a:t>
+            </a:r>
+            <a:endParaRPr lang="en-US" sz="1500" dirty="0"/>
           </a:p>
         </p:txBody>
       </p:sp>
@@ -1465,8 +1554,109 @@
         </p:nvSpPr>
         <p:spPr>
           <a:xfrm>
-            <a:off x="7452360" y="960120"/>
-            <a:ext cx="3886200" cy="4480560"/>
+            <a:off x="603504" y="4251960"/>
+            <a:ext cx="2788920" cy="1298448"/>
+          </a:xfrm>
+          <a:prstGeom prst="rect">
+            <a:avLst/>
+          </a:prstGeom>
+          <a:solidFill>
+            <a:srgbClr val="18231B"/>
+          </a:solidFill>
+          <a:ln w="16510">
+            <a:solidFill>
+              <a:srgbClr val="8BD8A8"/>
+            </a:solidFill>
+            <a:prstDash val="solid"/>
+          </a:ln>
+        </p:spPr>
+      </p:sp>
+      <p:sp>
+        <p:nvSpPr>
+          <p:cNvPr id="7" name="Text 5"/>
+          <p:cNvSpPr/>
+          <p:nvPr/>
+        </p:nvSpPr>
+        <p:spPr>
+          <a:xfrm>
+            <a:off x="841248" y="4434840"/>
+            <a:ext cx="2286000" cy="502920"/>
+          </a:xfrm>
+          <a:prstGeom prst="rect">
+            <a:avLst/>
+          </a:prstGeom>
+          <a:noFill/>
+          <a:ln/>
+        </p:spPr>
+        <p:txBody>
+          <a:bodyPr wrap="square" rtlCol="0" anchor="ctr">
+            <a:normAutofit/>
+          </a:bodyPr>
+          <a:lstStyle/>
+          <a:p>
+            <a:pPr indent="0" marL="0">
+              <a:buNone/>
+            </a:pPr>
+            <a:r>
+              <a:rPr lang="en-US" sz="3000" b="1" dirty="0">
+                <a:solidFill>
+                  <a:srgbClr val="F7F3E8"/>
+                </a:solidFill>
+              </a:rPr>
+              <a:t>$0.39</a:t>
+            </a:r>
+            <a:endParaRPr lang="en-US" sz="3000" dirty="0"/>
+          </a:p>
+        </p:txBody>
+      </p:sp>
+      <p:sp>
+        <p:nvSpPr>
+          <p:cNvPr id="8" name="Text 6"/>
+          <p:cNvSpPr/>
+          <p:nvPr/>
+        </p:nvSpPr>
+        <p:spPr>
+          <a:xfrm>
+            <a:off x="841248" y="4956048"/>
+            <a:ext cx="2286000" cy="320040"/>
+          </a:xfrm>
+          <a:prstGeom prst="rect">
+            <a:avLst/>
+          </a:prstGeom>
+          <a:noFill/>
+          <a:ln/>
+        </p:spPr>
+        <p:txBody>
+          <a:bodyPr wrap="square" rtlCol="0" anchor="ctr">
+            <a:normAutofit/>
+          </a:bodyPr>
+          <a:lstStyle/>
+          <a:p>
+            <a:pPr indent="0" marL="0">
+              <a:buNone/>
+            </a:pPr>
+            <a:r>
+              <a:rPr lang="en-US" sz="1050" dirty="0">
+                <a:solidFill>
+                  <a:srgbClr val="AAA79D"/>
+                </a:solidFill>
+              </a:rPr>
+              <a:t>proof spend controls $50K in capital exposure</a:t>
+            </a:r>
+            <a:endParaRPr lang="en-US" sz="1050" dirty="0"/>
+          </a:p>
+        </p:txBody>
+      </p:sp>
+      <p:sp>
+        <p:nvSpPr>
+          <p:cNvPr id="9" name="Shape 7"/>
+          <p:cNvSpPr/>
+          <p:nvPr/>
+        </p:nvSpPr>
+        <p:spPr>
+          <a:xfrm>
+            <a:off x="7022592" y="713232"/>
+            <a:ext cx="4434840" cy="5230368"/>
           </a:xfrm>
           <a:prstGeom prst="rect">
             <a:avLst/>
@@ -1476,7 +1666,7 @@
           </a:solidFill>
           <a:ln w="12700">
             <a:solidFill>
-              <a:srgbClr val="8BD8A8"/>
+              <a:srgbClr val="3A3D32"/>
             </a:solidFill>
             <a:prstDash val="solid"/>
           </a:ln>
@@ -1484,14 +1674,14 @@
       </p:sp>
       <p:sp>
         <p:nvSpPr>
-          <p:cNvPr id="7" name="Text 5"/>
-          <p:cNvSpPr/>
-          <p:nvPr/>
-        </p:nvSpPr>
-        <p:spPr>
-          <a:xfrm>
-            <a:off x="7818120" y="1417320"/>
-            <a:ext cx="3246120" cy="3383280"/>
+          <p:cNvPr id="10" name="Text 8"/>
+          <p:cNvSpPr/>
+          <p:nvPr/>
+        </p:nvSpPr>
+        <p:spPr>
+          <a:xfrm>
+            <a:off x="7370064" y="1143000"/>
+            <a:ext cx="3703320" cy="4069080"/>
           </a:xfrm>
           <a:prstGeom prst="rect">
             <a:avLst/>
@@ -1509,55 +1699,55 @@
               <a:buNone/>
             </a:pPr>
             <a:r>
-              <a:rPr lang="en-US" sz="1700" dirty="0">
-                <a:solidFill>
-                  <a:srgbClr val="F4F1E9"/>
-                </a:solidFill>
-              </a:rPr>
-              <a:t>• x402-style paid proof gates</a:t>
-            </a:r>
-            <a:endParaRPr lang="en-US" sz="1700" dirty="0"/>
-          </a:p>
-          <a:p>
-            <a:pPr indent="0" marL="0">
-              <a:buNone/>
-            </a:pPr>
-            <a:r>
-              <a:rPr lang="en-US" sz="1700" dirty="0">
-                <a:solidFill>
-                  <a:srgbClr val="F4F1E9"/>
+              <a:rPr lang="en-US" sz="1600" b="1" dirty="0">
+                <a:solidFill>
+                  <a:srgbClr val="F7F3E8"/>
+                </a:solidFill>
+              </a:rPr>
+              <a:t>• x402-style proof gates</a:t>
+            </a:r>
+            <a:endParaRPr lang="en-US" sz="1600" dirty="0"/>
+          </a:p>
+          <a:p>
+            <a:pPr indent="0" marL="0">
+              <a:buNone/>
+            </a:pPr>
+            <a:r>
+              <a:rPr lang="en-US" sz="1600" b="1" dirty="0">
+                <a:solidFill>
+                  <a:srgbClr val="F7F3E8"/>
                 </a:solidFill>
               </a:rPr>
               <a:t>• Gemini extraction</a:t>
             </a:r>
-            <a:endParaRPr lang="en-US" sz="1700" dirty="0"/>
-          </a:p>
-          <a:p>
-            <a:pPr indent="0" marL="0">
-              <a:buNone/>
-            </a:pPr>
-            <a:r>
-              <a:rPr lang="en-US" sz="1700" dirty="0">
-                <a:solidFill>
-                  <a:srgbClr val="F4F1E9"/>
-                </a:solidFill>
-              </a:rPr>
-              <a:t>• Vultr-backed ledger</a:t>
-            </a:r>
-            <a:endParaRPr lang="en-US" sz="1700" dirty="0"/>
-          </a:p>
-        </p:txBody>
-      </p:sp>
-      <p:sp>
-        <p:nvSpPr>
-          <p:cNvPr id="8" name="Text 6"/>
-          <p:cNvSpPr/>
-          <p:nvPr/>
-        </p:nvSpPr>
-        <p:spPr>
-          <a:xfrm>
-            <a:off x="10716768" y="6080760"/>
-            <a:ext cx="731520" cy="182880"/>
+            <a:endParaRPr lang="en-US" sz="1600" dirty="0"/>
+          </a:p>
+          <a:p>
+            <a:pPr indent="0" marL="0">
+              <a:buNone/>
+            </a:pPr>
+            <a:r>
+              <a:rPr lang="en-US" sz="1600" b="1" dirty="0">
+                <a:solidFill>
+                  <a:srgbClr val="F7F3E8"/>
+                </a:solidFill>
+              </a:rPr>
+              <a:t>• Vultr Postgres ledger</a:t>
+            </a:r>
+            <a:endParaRPr lang="en-US" sz="1600" dirty="0"/>
+          </a:p>
+        </p:txBody>
+      </p:sp>
+      <p:sp>
+        <p:nvSpPr>
+          <p:cNvPr id="11" name="Text 9"/>
+          <p:cNvSpPr/>
+          <p:nvPr/>
+        </p:nvSpPr>
+        <p:spPr>
+          <a:xfrm>
+            <a:off x="10643616" y="6236208"/>
+            <a:ext cx="685800" cy="164592"/>
           </a:xfrm>
           <a:prstGeom prst="rect">
             <a:avLst/>
@@ -1578,7 +1768,7 @@
                   <a:srgbClr val="C9B98B"/>
                 </a:solidFill>
               </a:rPr>
-              <a:t>1 / 6</a:t>
+              <a:t>1 / 7</a:t>
             </a:r>
             <a:endParaRPr lang="en-US" sz="900" dirty="0"/>
           </a:p>
@@ -1598,7 +1788,7 @@
     <p:bg>
       <p:bgPr>
         <a:solidFill>
-          <a:srgbClr val="10110F"/>
+          <a:srgbClr val="0B0C0A"/>
         </a:solidFill>
       </p:bgPr>
     </p:bg>
@@ -1624,18 +1814,18 @@
         </p:nvSpPr>
         <p:spPr>
           <a:xfrm>
-            <a:off x="320040" y="320040"/>
-            <a:ext cx="11548872" cy="6217920"/>
+            <a:off x="256032" y="256032"/>
+            <a:ext cx="11686032" cy="6355080"/>
           </a:xfrm>
           <a:prstGeom prst="rect">
             <a:avLst/>
           </a:prstGeom>
           <a:solidFill>
-            <a:srgbClr val="191B17"/>
+            <a:srgbClr val="12140F"/>
           </a:solidFill>
           <a:ln w="12700">
             <a:solidFill>
-              <a:srgbClr val="393A31"/>
+              <a:srgbClr val="3A3D32"/>
             </a:solidFill>
             <a:prstDash val="solid"/>
           </a:ln>
@@ -1649,8 +1839,8 @@
         </p:nvSpPr>
         <p:spPr>
           <a:xfrm>
-            <a:off x="594360" y="640080"/>
-            <a:ext cx="3108960" cy="228600"/>
+            <a:off x="566928" y="621792"/>
+            <a:ext cx="2926080" cy="237744"/>
           </a:xfrm>
           <a:prstGeom prst="rect">
             <a:avLst/>
@@ -1671,7 +1861,7 @@
                   <a:srgbClr val="C9B98B"/>
                 </a:solidFill>
               </a:rPr>
-              <a:t>PROBLEM</a:t>
+              <a:t>02 / WHY NOW</a:t>
             </a:r>
             <a:endParaRPr lang="en-US" sz="1000" dirty="0"/>
           </a:p>
@@ -1685,8 +1875,8 @@
         </p:nvSpPr>
         <p:spPr>
           <a:xfrm>
-            <a:off x="594360" y="1005840"/>
-            <a:ext cx="6537960" cy="1188720"/>
+            <a:off x="566928" y="960120"/>
+            <a:ext cx="6080760" cy="1508760"/>
           </a:xfrm>
           <a:prstGeom prst="rect">
             <a:avLst/>
@@ -1706,10 +1896,10 @@
             <a:r>
               <a:rPr lang="en-US" sz="3100" b="1" dirty="0">
                 <a:solidFill>
-                  <a:srgbClr val="F4F1E9"/>
-                </a:solidFill>
-              </a:rPr>
-              <a:t>Autonomous agents can move faster than treasury controls</a:t>
+                  <a:srgbClr val="F7F3E8"/>
+                </a:solidFill>
+              </a:rPr>
+              <a:t>AI agents are crossing from advice into authorization.</a:t>
             </a:r>
             <a:endParaRPr lang="en-US" sz="3100" dirty="0"/>
           </a:p>
@@ -1723,8 +1913,8 @@
         </p:nvSpPr>
         <p:spPr>
           <a:xfrm>
-            <a:off x="621792" y="2423160"/>
-            <a:ext cx="5989320" cy="1280160"/>
+            <a:off x="594360" y="2615184"/>
+            <a:ext cx="5650992" cy="1097280"/>
           </a:xfrm>
           <a:prstGeom prst="rect">
             <a:avLst/>
@@ -1742,14 +1932,14 @@
               <a:buNone/>
             </a:pPr>
             <a:r>
-              <a:rPr lang="en-US" sz="1600" dirty="0">
+              <a:rPr lang="en-US" sz="1500" dirty="0">
                 <a:solidFill>
                   <a:srgbClr val="AAA79D"/>
                 </a:solidFill>
               </a:rPr>
-              <a:t>AI agents can parse invoices and trigger workflows, but most financial controls still rely on after-the-fact dashboards or human review queues.</a:t>
-            </a:r>
-            <a:endParaRPr lang="en-US" sz="1600" dirty="0"/>
+              <a:t>Summaries are not proof. A payout agent needs a pre-payout enforcement layer, not another dashboard after the money is gone.</a:t>
+            </a:r>
+            <a:endParaRPr lang="en-US" sz="1500" dirty="0"/>
           </a:p>
         </p:txBody>
       </p:sp>
@@ -1761,8 +1951,109 @@
         </p:nvSpPr>
         <p:spPr>
           <a:xfrm>
-            <a:off x="7452360" y="960120"/>
-            <a:ext cx="3886200" cy="4480560"/>
+            <a:off x="603504" y="4251960"/>
+            <a:ext cx="2788920" cy="1298448"/>
+          </a:xfrm>
+          <a:prstGeom prst="rect">
+            <a:avLst/>
+          </a:prstGeom>
+          <a:solidFill>
+            <a:srgbClr val="18231B"/>
+          </a:solidFill>
+          <a:ln w="16510">
+            <a:solidFill>
+              <a:srgbClr val="8BD8A8"/>
+            </a:solidFill>
+            <a:prstDash val="solid"/>
+          </a:ln>
+        </p:spPr>
+      </p:sp>
+      <p:sp>
+        <p:nvSpPr>
+          <p:cNvPr id="7" name="Text 5"/>
+          <p:cNvSpPr/>
+          <p:nvPr/>
+        </p:nvSpPr>
+        <p:spPr>
+          <a:xfrm>
+            <a:off x="841248" y="4434840"/>
+            <a:ext cx="2286000" cy="502920"/>
+          </a:xfrm>
+          <a:prstGeom prst="rect">
+            <a:avLst/>
+          </a:prstGeom>
+          <a:noFill/>
+          <a:ln/>
+        </p:spPr>
+        <p:txBody>
+          <a:bodyPr wrap="square" rtlCol="0" anchor="ctr">
+            <a:normAutofit/>
+          </a:bodyPr>
+          <a:lstStyle/>
+          <a:p>
+            <a:pPr indent="0" marL="0">
+              <a:buNone/>
+            </a:pPr>
+            <a:r>
+              <a:rPr lang="en-US" sz="3000" b="1" dirty="0">
+                <a:solidFill>
+                  <a:srgbClr val="F7F3E8"/>
+                </a:solidFill>
+              </a:rPr>
+              <a:t>$75K</a:t>
+            </a:r>
+            <a:endParaRPr lang="en-US" sz="3000" dirty="0"/>
+          </a:p>
+        </p:txBody>
+      </p:sp>
+      <p:sp>
+        <p:nvSpPr>
+          <p:cNvPr id="8" name="Text 6"/>
+          <p:cNvSpPr/>
+          <p:nvPr/>
+        </p:nvSpPr>
+        <p:spPr>
+          <a:xfrm>
+            <a:off x="841248" y="4956048"/>
+            <a:ext cx="2286000" cy="320040"/>
+          </a:xfrm>
+          <a:prstGeom prst="rect">
+            <a:avLst/>
+          </a:prstGeom>
+          <a:noFill/>
+          <a:ln/>
+        </p:spPr>
+        <p:txBody>
+          <a:bodyPr wrap="square" rtlCol="0" anchor="ctr">
+            <a:normAutofit/>
+          </a:bodyPr>
+          <a:lstStyle/>
+          <a:p>
+            <a:pPr indent="0" marL="0">
+              <a:buNone/>
+            </a:pPr>
+            <a:r>
+              <a:rPr lang="en-US" sz="1050" dirty="0">
+                <a:solidFill>
+                  <a:srgbClr val="AAA79D"/>
+                </a:solidFill>
+              </a:rPr>
+              <a:t>sample payout request held before release</a:t>
+            </a:r>
+            <a:endParaRPr lang="en-US" sz="1050" dirty="0"/>
+          </a:p>
+        </p:txBody>
+      </p:sp>
+      <p:sp>
+        <p:nvSpPr>
+          <p:cNvPr id="9" name="Shape 7"/>
+          <p:cNvSpPr/>
+          <p:nvPr/>
+        </p:nvSpPr>
+        <p:spPr>
+          <a:xfrm>
+            <a:off x="7022592" y="713232"/>
+            <a:ext cx="4434840" cy="5230368"/>
           </a:xfrm>
           <a:prstGeom prst="rect">
             <a:avLst/>
@@ -1772,7 +2063,7 @@
           </a:solidFill>
           <a:ln w="12700">
             <a:solidFill>
-              <a:srgbClr val="393A31"/>
+              <a:srgbClr val="3A3D32"/>
             </a:solidFill>
             <a:prstDash val="solid"/>
           </a:ln>
@@ -1780,14 +2071,14 @@
       </p:sp>
       <p:sp>
         <p:nvSpPr>
-          <p:cNvPr id="7" name="Text 5"/>
-          <p:cNvSpPr/>
-          <p:nvPr/>
-        </p:nvSpPr>
-        <p:spPr>
-          <a:xfrm>
-            <a:off x="7818120" y="1417320"/>
-            <a:ext cx="3246120" cy="3383280"/>
+          <p:cNvPr id="10" name="Text 8"/>
+          <p:cNvSpPr/>
+          <p:nvPr/>
+        </p:nvSpPr>
+        <p:spPr>
+          <a:xfrm>
+            <a:off x="7370064" y="1143000"/>
+            <a:ext cx="3703320" cy="4069080"/>
           </a:xfrm>
           <a:prstGeom prst="rect">
             <a:avLst/>
@@ -1805,55 +2096,55 @@
               <a:buNone/>
             </a:pPr>
             <a:r>
-              <a:rPr lang="en-US" sz="1700" dirty="0">
-                <a:solidFill>
-                  <a:srgbClr val="F4F1E9"/>
+              <a:rPr lang="en-US" sz="1600" b="1" dirty="0">
+                <a:solidFill>
+                  <a:srgbClr val="F7F3E8"/>
                 </a:solidFill>
               </a:rPr>
               <a:t>• Risk appears before audit</a:t>
             </a:r>
-            <a:endParaRPr lang="en-US" sz="1700" dirty="0"/>
-          </a:p>
-          <a:p>
-            <a:pPr indent="0" marL="0">
-              <a:buNone/>
-            </a:pPr>
-            <a:r>
-              <a:rPr lang="en-US" sz="1700" dirty="0">
-                <a:solidFill>
-                  <a:srgbClr val="F4F1E9"/>
-                </a:solidFill>
-              </a:rPr>
-              <a:t>• Summaries are not proof</a:t>
-            </a:r>
-            <a:endParaRPr lang="en-US" sz="1700" dirty="0"/>
-          </a:p>
-          <a:p>
-            <a:pPr indent="0" marL="0">
-              <a:buNone/>
-            </a:pPr>
-            <a:r>
-              <a:rPr lang="en-US" sz="1700" dirty="0">
-                <a:solidFill>
-                  <a:srgbClr val="F4F1E9"/>
-                </a:solidFill>
-              </a:rPr>
-              <a:t>• Payment authorization needs an enforceable pre-payout gate</a:t>
-            </a:r>
-            <a:endParaRPr lang="en-US" sz="1700" dirty="0"/>
-          </a:p>
-        </p:txBody>
-      </p:sp>
-      <p:sp>
-        <p:nvSpPr>
-          <p:cNvPr id="8" name="Text 6"/>
-          <p:cNvSpPr/>
-          <p:nvPr/>
-        </p:nvSpPr>
-        <p:spPr>
-          <a:xfrm>
-            <a:off x="10716768" y="6080760"/>
-            <a:ext cx="731520" cy="182880"/>
+            <a:endParaRPr lang="en-US" sz="1600" dirty="0"/>
+          </a:p>
+          <a:p>
+            <a:pPr indent="0" marL="0">
+              <a:buNone/>
+            </a:pPr>
+            <a:r>
+              <a:rPr lang="en-US" sz="1600" b="1" dirty="0">
+                <a:solidFill>
+                  <a:srgbClr val="F7F3E8"/>
+                </a:solidFill>
+              </a:rPr>
+              <a:t>• Human queues do not scale</a:t>
+            </a:r>
+            <a:endParaRPr lang="en-US" sz="1600" dirty="0"/>
+          </a:p>
+          <a:p>
+            <a:pPr indent="0" marL="0">
+              <a:buNone/>
+            </a:pPr>
+            <a:r>
+              <a:rPr lang="en-US" sz="1600" b="1" dirty="0">
+                <a:solidFill>
+                  <a:srgbClr val="F7F3E8"/>
+                </a:solidFill>
+              </a:rPr>
+              <a:t>• Treasury needs machine-verifiable clearance</a:t>
+            </a:r>
+            <a:endParaRPr lang="en-US" sz="1600" dirty="0"/>
+          </a:p>
+        </p:txBody>
+      </p:sp>
+      <p:sp>
+        <p:nvSpPr>
+          <p:cNvPr id="11" name="Text 9"/>
+          <p:cNvSpPr/>
+          <p:nvPr/>
+        </p:nvSpPr>
+        <p:spPr>
+          <a:xfrm>
+            <a:off x="10643616" y="6236208"/>
+            <a:ext cx="685800" cy="164592"/>
           </a:xfrm>
           <a:prstGeom prst="rect">
             <a:avLst/>
@@ -1874,7 +2165,7 @@
                   <a:srgbClr val="C9B98B"/>
                 </a:solidFill>
               </a:rPr>
-              <a:t>2 / 6</a:t>
+              <a:t>2 / 7</a:t>
             </a:r>
             <a:endParaRPr lang="en-US" sz="900" dirty="0"/>
           </a:p>
@@ -1894,7 +2185,7 @@
     <p:bg>
       <p:bgPr>
         <a:solidFill>
-          <a:srgbClr val="10110F"/>
+          <a:srgbClr val="0B0C0A"/>
         </a:solidFill>
       </p:bgPr>
     </p:bg>
@@ -1920,18 +2211,18 @@
         </p:nvSpPr>
         <p:spPr>
           <a:xfrm>
-            <a:off x="320040" y="320040"/>
-            <a:ext cx="11548872" cy="6217920"/>
+            <a:off x="256032" y="256032"/>
+            <a:ext cx="11686032" cy="6355080"/>
           </a:xfrm>
           <a:prstGeom prst="rect">
             <a:avLst/>
           </a:prstGeom>
           <a:solidFill>
-            <a:srgbClr val="191B17"/>
+            <a:srgbClr val="12140F"/>
           </a:solidFill>
           <a:ln w="12700">
             <a:solidFill>
-              <a:srgbClr val="393A31"/>
+              <a:srgbClr val="3A3D32"/>
             </a:solidFill>
             <a:prstDash val="solid"/>
           </a:ln>
@@ -1945,8 +2236,8 @@
         </p:nvSpPr>
         <p:spPr>
           <a:xfrm>
-            <a:off x="594360" y="640080"/>
-            <a:ext cx="3108960" cy="228600"/>
+            <a:off x="566928" y="621792"/>
+            <a:ext cx="2926080" cy="237744"/>
           </a:xfrm>
           <a:prstGeom prst="rect">
             <a:avLst/>
@@ -1967,7 +2258,7 @@
                   <a:srgbClr val="C9B98B"/>
                 </a:solidFill>
               </a:rPr>
-              <a:t>SOLUTION</a:t>
+              <a:t>03 / PAID PROOF</a:t>
             </a:r>
             <a:endParaRPr lang="en-US" sz="1000" dirty="0"/>
           </a:p>
@@ -1981,8 +2272,8 @@
         </p:nvSpPr>
         <p:spPr>
           <a:xfrm>
-            <a:off x="594360" y="1005840"/>
-            <a:ext cx="6537960" cy="1188720"/>
+            <a:off x="566928" y="960120"/>
+            <a:ext cx="6080760" cy="1508760"/>
           </a:xfrm>
           <a:prstGeom prst="rect">
             <a:avLst/>
@@ -2002,10 +2293,10 @@
             <a:r>
               <a:rPr lang="en-US" sz="3100" b="1" dirty="0">
                 <a:solidFill>
-                  <a:srgbClr val="F4F1E9"/>
-                </a:solidFill>
-              </a:rPr>
-              <a:t>Turn proof into a paid prerequisite</a:t>
+                  <a:srgbClr val="F7F3E8"/>
+                </a:solidFill>
+              </a:rPr>
+              <a:t>Evidence is protected by payment, not trust.</a:t>
             </a:r>
             <a:endParaRPr lang="en-US" sz="3100" dirty="0"/>
           </a:p>
@@ -2019,8 +2310,8 @@
         </p:nvSpPr>
         <p:spPr>
           <a:xfrm>
-            <a:off x="621792" y="2423160"/>
-            <a:ext cx="5989320" cy="1280160"/>
+            <a:off x="594360" y="2615184"/>
+            <a:ext cx="5650992" cy="1097280"/>
           </a:xfrm>
           <a:prstGeom prst="rect">
             <a:avLst/>
@@ -2038,14 +2329,14 @@
               <a:buNone/>
             </a:pPr>
             <a:r>
-              <a:rPr lang="en-US" sz="1600" dirty="0">
+              <a:rPr lang="en-US" sz="1500" dirty="0">
                 <a:solidFill>
                   <a:srgbClr val="AAA79D"/>
                 </a:solidFill>
               </a:rPr>
-              <a:t>The agent must request protected evidence endpoints, receive HTTP 402 payment metadata, buy proof receipts, and only then ask Policy Guard to decide.</a:t>
-            </a:r>
-            <a:endParaRPr lang="en-US" sz="1600" dirty="0"/>
+              <a:t>Proof endpoints return HTTP 402 until the agent pays. Only paid receipts can enter the treasury policy decision.</a:t>
+            </a:r>
+            <a:endParaRPr lang="en-US" sz="1500" dirty="0"/>
           </a:p>
         </p:txBody>
       </p:sp>
@@ -2057,8 +2348,109 @@
         </p:nvSpPr>
         <p:spPr>
           <a:xfrm>
-            <a:off x="7452360" y="960120"/>
-            <a:ext cx="3886200" cy="4480560"/>
+            <a:off x="603504" y="4251960"/>
+            <a:ext cx="2788920" cy="1298448"/>
+          </a:xfrm>
+          <a:prstGeom prst="rect">
+            <a:avLst/>
+          </a:prstGeom>
+          <a:solidFill>
+            <a:srgbClr val="1D1618"/>
+          </a:solidFill>
+          <a:ln w="16510">
+            <a:solidFill>
+              <a:srgbClr val="F08BA0"/>
+            </a:solidFill>
+            <a:prstDash val="solid"/>
+          </a:ln>
+        </p:spPr>
+      </p:sp>
+      <p:sp>
+        <p:nvSpPr>
+          <p:cNvPr id="7" name="Text 5"/>
+          <p:cNvSpPr/>
+          <p:nvPr/>
+        </p:nvSpPr>
+        <p:spPr>
+          <a:xfrm>
+            <a:off x="841248" y="4434840"/>
+            <a:ext cx="2286000" cy="502920"/>
+          </a:xfrm>
+          <a:prstGeom prst="rect">
+            <a:avLst/>
+          </a:prstGeom>
+          <a:noFill/>
+          <a:ln/>
+        </p:spPr>
+        <p:txBody>
+          <a:bodyPr wrap="square" rtlCol="0" anchor="ctr">
+            <a:normAutofit/>
+          </a:bodyPr>
+          <a:lstStyle/>
+          <a:p>
+            <a:pPr indent="0" marL="0">
+              <a:buNone/>
+            </a:pPr>
+            <a:r>
+              <a:rPr lang="en-US" sz="3000" b="1" dirty="0">
+                <a:solidFill>
+                  <a:srgbClr val="F7F3E8"/>
+                </a:solidFill>
+              </a:rPr>
+              <a:t>402</a:t>
+            </a:r>
+            <a:endParaRPr lang="en-US" sz="3000" dirty="0"/>
+          </a:p>
+        </p:txBody>
+      </p:sp>
+      <p:sp>
+        <p:nvSpPr>
+          <p:cNvPr id="8" name="Text 6"/>
+          <p:cNvSpPr/>
+          <p:nvPr/>
+        </p:nvSpPr>
+        <p:spPr>
+          <a:xfrm>
+            <a:off x="841248" y="4956048"/>
+            <a:ext cx="2286000" cy="320040"/>
+          </a:xfrm>
+          <a:prstGeom prst="rect">
+            <a:avLst/>
+          </a:prstGeom>
+          <a:noFill/>
+          <a:ln/>
+        </p:spPr>
+        <p:txBody>
+          <a:bodyPr wrap="square" rtlCol="0" anchor="ctr">
+            <a:normAutofit/>
+          </a:bodyPr>
+          <a:lstStyle/>
+          <a:p>
+            <a:pPr indent="0" marL="0">
+              <a:buNone/>
+            </a:pPr>
+            <a:r>
+              <a:rPr lang="en-US" sz="1050" dirty="0">
+                <a:solidFill>
+                  <a:srgbClr val="AAA79D"/>
+                </a:solidFill>
+              </a:rPr>
+              <a:t>payment required before proof access</a:t>
+            </a:r>
+            <a:endParaRPr lang="en-US" sz="1050" dirty="0"/>
+          </a:p>
+        </p:txBody>
+      </p:sp>
+      <p:sp>
+        <p:nvSpPr>
+          <p:cNvPr id="9" name="Shape 7"/>
+          <p:cNvSpPr/>
+          <p:nvPr/>
+        </p:nvSpPr>
+        <p:spPr>
+          <a:xfrm>
+            <a:off x="7022592" y="713232"/>
+            <a:ext cx="4434840" cy="5230368"/>
           </a:xfrm>
           <a:prstGeom prst="rect">
             <a:avLst/>
@@ -2068,7 +2460,7 @@
           </a:solidFill>
           <a:ln w="12700">
             <a:solidFill>
-              <a:srgbClr val="393A31"/>
+              <a:srgbClr val="3A3D32"/>
             </a:solidFill>
             <a:prstDash val="solid"/>
           </a:ln>
@@ -2076,14 +2468,14 @@
       </p:sp>
       <p:sp>
         <p:nvSpPr>
-          <p:cNvPr id="7" name="Text 5"/>
-          <p:cNvSpPr/>
-          <p:nvPr/>
-        </p:nvSpPr>
-        <p:spPr>
-          <a:xfrm>
-            <a:off x="7818120" y="1417320"/>
-            <a:ext cx="3246120" cy="3383280"/>
+          <p:cNvPr id="10" name="Text 8"/>
+          <p:cNvSpPr/>
+          <p:nvPr/>
+        </p:nvSpPr>
+        <p:spPr>
+          <a:xfrm>
+            <a:off x="7370064" y="1143000"/>
+            <a:ext cx="3703320" cy="4069080"/>
           </a:xfrm>
           <a:prstGeom prst="rect">
             <a:avLst/>
@@ -2101,69 +2493,69 @@
               <a:buNone/>
             </a:pPr>
             <a:r>
-              <a:rPr lang="en-US" sz="1700" dirty="0">
-                <a:solidFill>
-                  <a:srgbClr val="F4F1E9"/>
-                </a:solidFill>
-              </a:rPr>
-              <a:t>• Vendor-risk proof</a:t>
-            </a:r>
-            <a:endParaRPr lang="en-US" sz="1700" dirty="0"/>
-          </a:p>
-          <a:p>
-            <a:pPr indent="0" marL="0">
-              <a:buNone/>
-            </a:pPr>
-            <a:r>
-              <a:rPr lang="en-US" sz="1700" dirty="0">
-                <a:solidFill>
-                  <a:srgbClr val="F4F1E9"/>
-                </a:solidFill>
-              </a:rPr>
-              <a:t>• Recipient-match proof</a:t>
-            </a:r>
-            <a:endParaRPr lang="en-US" sz="1700" dirty="0"/>
-          </a:p>
-          <a:p>
-            <a:pPr indent="0" marL="0">
-              <a:buNone/>
-            </a:pPr>
-            <a:r>
-              <a:rPr lang="en-US" sz="1700" dirty="0">
-                <a:solidFill>
-                  <a:srgbClr val="F4F1E9"/>
-                </a:solidFill>
-              </a:rPr>
-              <a:t>• Sanctions-screen proof</a:t>
-            </a:r>
-            <a:endParaRPr lang="en-US" sz="1700" dirty="0"/>
-          </a:p>
-          <a:p>
-            <a:pPr indent="0" marL="0">
-              <a:buNone/>
-            </a:pPr>
-            <a:r>
-              <a:rPr lang="en-US" sz="1700" dirty="0">
-                <a:solidFill>
-                  <a:srgbClr val="F4F1E9"/>
-                </a:solidFill>
-              </a:rPr>
-              <a:t>• Delivery-attestation proof</a:t>
-            </a:r>
-            <a:endParaRPr lang="en-US" sz="1700" dirty="0"/>
-          </a:p>
-        </p:txBody>
-      </p:sp>
-      <p:sp>
-        <p:nvSpPr>
-          <p:cNvPr id="8" name="Text 6"/>
-          <p:cNvSpPr/>
-          <p:nvPr/>
-        </p:nvSpPr>
-        <p:spPr>
-          <a:xfrm>
-            <a:off x="10716768" y="6080760"/>
-            <a:ext cx="731520" cy="182880"/>
+              <a:rPr lang="en-US" sz="1600" b="1" dirty="0">
+                <a:solidFill>
+                  <a:srgbClr val="F7F3E8"/>
+                </a:solidFill>
+              </a:rPr>
+              <a:t>• vendor-risk</a:t>
+            </a:r>
+            <a:endParaRPr lang="en-US" sz="1600" dirty="0"/>
+          </a:p>
+          <a:p>
+            <a:pPr indent="0" marL="0">
+              <a:buNone/>
+            </a:pPr>
+            <a:r>
+              <a:rPr lang="en-US" sz="1600" b="1" dirty="0">
+                <a:solidFill>
+                  <a:srgbClr val="F7F3E8"/>
+                </a:solidFill>
+              </a:rPr>
+              <a:t>• recipient-match</a:t>
+            </a:r>
+            <a:endParaRPr lang="en-US" sz="1600" dirty="0"/>
+          </a:p>
+          <a:p>
+            <a:pPr indent="0" marL="0">
+              <a:buNone/>
+            </a:pPr>
+            <a:r>
+              <a:rPr lang="en-US" sz="1600" b="1" dirty="0">
+                <a:solidFill>
+                  <a:srgbClr val="F7F3E8"/>
+                </a:solidFill>
+              </a:rPr>
+              <a:t>• sanctions-screen</a:t>
+            </a:r>
+            <a:endParaRPr lang="en-US" sz="1600" dirty="0"/>
+          </a:p>
+          <a:p>
+            <a:pPr indent="0" marL="0">
+              <a:buNone/>
+            </a:pPr>
+            <a:r>
+              <a:rPr lang="en-US" sz="1600" b="1" dirty="0">
+                <a:solidFill>
+                  <a:srgbClr val="F7F3E8"/>
+                </a:solidFill>
+              </a:rPr>
+              <a:t>• delivery-attestation</a:t>
+            </a:r>
+            <a:endParaRPr lang="en-US" sz="1600" dirty="0"/>
+          </a:p>
+        </p:txBody>
+      </p:sp>
+      <p:sp>
+        <p:nvSpPr>
+          <p:cNvPr id="11" name="Text 9"/>
+          <p:cNvSpPr/>
+          <p:nvPr/>
+        </p:nvSpPr>
+        <p:spPr>
+          <a:xfrm>
+            <a:off x="10643616" y="6236208"/>
+            <a:ext cx="685800" cy="164592"/>
           </a:xfrm>
           <a:prstGeom prst="rect">
             <a:avLst/>
@@ -2184,7 +2576,7 @@
                   <a:srgbClr val="C9B98B"/>
                 </a:solidFill>
               </a:rPr>
-              <a:t>3 / 6</a:t>
+              <a:t>3 / 7</a:t>
             </a:r>
             <a:endParaRPr lang="en-US" sz="900" dirty="0"/>
           </a:p>
@@ -2204,7 +2596,7 @@
     <p:bg>
       <p:bgPr>
         <a:solidFill>
-          <a:srgbClr val="10110F"/>
+          <a:srgbClr val="0B0C0A"/>
         </a:solidFill>
       </p:bgPr>
     </p:bg>
@@ -2230,18 +2622,18 @@
         </p:nvSpPr>
         <p:spPr>
           <a:xfrm>
-            <a:off x="320040" y="320040"/>
-            <a:ext cx="11548872" cy="6217920"/>
+            <a:off x="256032" y="256032"/>
+            <a:ext cx="11686032" cy="6355080"/>
           </a:xfrm>
           <a:prstGeom prst="rect">
             <a:avLst/>
           </a:prstGeom>
           <a:solidFill>
-            <a:srgbClr val="191B17"/>
+            <a:srgbClr val="12140F"/>
           </a:solidFill>
           <a:ln w="12700">
             <a:solidFill>
-              <a:srgbClr val="393A31"/>
+              <a:srgbClr val="3A3D32"/>
             </a:solidFill>
             <a:prstDash val="solid"/>
           </a:ln>
@@ -2255,8 +2647,8 @@
         </p:nvSpPr>
         <p:spPr>
           <a:xfrm>
-            <a:off x="594360" y="640080"/>
-            <a:ext cx="3108960" cy="228600"/>
+            <a:off x="566928" y="621792"/>
+            <a:ext cx="2926080" cy="237744"/>
           </a:xfrm>
           <a:prstGeom prst="rect">
             <a:avLst/>
@@ -2277,7 +2669,7 @@
                   <a:srgbClr val="C9B98B"/>
                 </a:solidFill>
               </a:rPr>
-              <a:t>AGENT FLOW</a:t>
+              <a:t>04 / AGENT WORKFLOW</a:t>
             </a:r>
             <a:endParaRPr lang="en-US" sz="1000" dirty="0"/>
           </a:p>
@@ -2291,8 +2683,8 @@
         </p:nvSpPr>
         <p:spPr>
           <a:xfrm>
-            <a:off x="594360" y="1005840"/>
-            <a:ext cx="6537960" cy="1188720"/>
+            <a:off x="566928" y="960120"/>
+            <a:ext cx="6080760" cy="1508760"/>
           </a:xfrm>
           <a:prstGeom prst="rect">
             <a:avLst/>
@@ -2312,10 +2704,10 @@
             <a:r>
               <a:rPr lang="en-US" sz="3100" b="1" dirty="0">
                 <a:solidFill>
-                  <a:srgbClr val="F4F1E9"/>
-                </a:solidFill>
-              </a:rPr>
-              <a:t>Every payout becomes a verifiable clearance run</a:t>
+                  <a:srgbClr val="F7F3E8"/>
+                </a:solidFill>
+              </a:rPr>
+              <a:t>The product is an acting agent, not a passive dashboard.</a:t>
             </a:r>
             <a:endParaRPr lang="en-US" sz="3100" dirty="0"/>
           </a:p>
@@ -2329,8 +2721,8 @@
         </p:nvSpPr>
         <p:spPr>
           <a:xfrm>
-            <a:off x="621792" y="2423160"/>
-            <a:ext cx="5989320" cy="1280160"/>
+            <a:off x="594360" y="2615184"/>
+            <a:ext cx="5650992" cy="1097280"/>
           </a:xfrm>
           <a:prstGeom prst="rect">
             <a:avLst/>
@@ -2348,14 +2740,14 @@
               <a:buNone/>
             </a:pPr>
             <a:r>
-              <a:rPr lang="en-US" sz="1600" dirty="0">
+              <a:rPr lang="en-US" sz="1500" dirty="0">
                 <a:solidFill>
                   <a:srgbClr val="AAA79D"/>
                 </a:solidFill>
               </a:rPr>
-              <a:t>Payout intent -&gt; Gemini extraction -&gt; proof plan -&gt; x402 proof gate -&gt; paid receipts -&gt; policy decision -&gt; signed ClearancePacket -&gt; ledger verification.</a:t>
-            </a:r>
-            <a:endParaRPr lang="en-US" sz="1600" dirty="0"/>
+              <a:t>Intake Agent extracts context, Proof Agent creates the plan, Payment Agent buys receipts, Policy Guard decides, and Audit Agent signs the packet.</a:t>
+            </a:r>
+            <a:endParaRPr lang="en-US" sz="1500" dirty="0"/>
           </a:p>
         </p:txBody>
       </p:sp>
@@ -2367,8 +2759,109 @@
         </p:nvSpPr>
         <p:spPr>
           <a:xfrm>
-            <a:off x="7452360" y="960120"/>
-            <a:ext cx="3886200" cy="4480560"/>
+            <a:off x="603504" y="4251960"/>
+            <a:ext cx="2788920" cy="1298448"/>
+          </a:xfrm>
+          <a:prstGeom prst="rect">
+            <a:avLst/>
+          </a:prstGeom>
+          <a:solidFill>
+            <a:srgbClr val="18231B"/>
+          </a:solidFill>
+          <a:ln w="16510">
+            <a:solidFill>
+              <a:srgbClr val="8BD8A8"/>
+            </a:solidFill>
+            <a:prstDash val="solid"/>
+          </a:ln>
+        </p:spPr>
+      </p:sp>
+      <p:sp>
+        <p:nvSpPr>
+          <p:cNvPr id="7" name="Text 5"/>
+          <p:cNvSpPr/>
+          <p:nvPr/>
+        </p:nvSpPr>
+        <p:spPr>
+          <a:xfrm>
+            <a:off x="841248" y="4434840"/>
+            <a:ext cx="2286000" cy="502920"/>
+          </a:xfrm>
+          <a:prstGeom prst="rect">
+            <a:avLst/>
+          </a:prstGeom>
+          <a:noFill/>
+          <a:ln/>
+        </p:spPr>
+        <p:txBody>
+          <a:bodyPr wrap="square" rtlCol="0" anchor="ctr">
+            <a:normAutofit/>
+          </a:bodyPr>
+          <a:lstStyle/>
+          <a:p>
+            <a:pPr indent="0" marL="0">
+              <a:buNone/>
+            </a:pPr>
+            <a:r>
+              <a:rPr lang="en-US" sz="3000" b="1" dirty="0">
+                <a:solidFill>
+                  <a:srgbClr val="F7F3E8"/>
+                </a:solidFill>
+              </a:rPr>
+              <a:t>5</a:t>
+            </a:r>
+            <a:endParaRPr lang="en-US" sz="3000" dirty="0"/>
+          </a:p>
+        </p:txBody>
+      </p:sp>
+      <p:sp>
+        <p:nvSpPr>
+          <p:cNvPr id="8" name="Text 6"/>
+          <p:cNvSpPr/>
+          <p:nvPr/>
+        </p:nvSpPr>
+        <p:spPr>
+          <a:xfrm>
+            <a:off x="841248" y="4956048"/>
+            <a:ext cx="2286000" cy="320040"/>
+          </a:xfrm>
+          <a:prstGeom prst="rect">
+            <a:avLst/>
+          </a:prstGeom>
+          <a:noFill/>
+          <a:ln/>
+        </p:spPr>
+        <p:txBody>
+          <a:bodyPr wrap="square" rtlCol="0" anchor="ctr">
+            <a:normAutofit/>
+          </a:bodyPr>
+          <a:lstStyle/>
+          <a:p>
+            <a:pPr indent="0" marL="0">
+              <a:buNone/>
+            </a:pPr>
+            <a:r>
+              <a:rPr lang="en-US" sz="1050" dirty="0">
+                <a:solidFill>
+                  <a:srgbClr val="AAA79D"/>
+                </a:solidFill>
+              </a:rPr>
+              <a:t>agents in one clearance loop</a:t>
+            </a:r>
+            <a:endParaRPr lang="en-US" sz="1050" dirty="0"/>
+          </a:p>
+        </p:txBody>
+      </p:sp>
+      <p:sp>
+        <p:nvSpPr>
+          <p:cNvPr id="9" name="Shape 7"/>
+          <p:cNvSpPr/>
+          <p:nvPr/>
+        </p:nvSpPr>
+        <p:spPr>
+          <a:xfrm>
+            <a:off x="7022592" y="713232"/>
+            <a:ext cx="4434840" cy="5230368"/>
           </a:xfrm>
           <a:prstGeom prst="rect">
             <a:avLst/>
@@ -2378,7 +2871,7 @@
           </a:solidFill>
           <a:ln w="12700">
             <a:solidFill>
-              <a:srgbClr val="393A31"/>
+              <a:srgbClr val="3A3D32"/>
             </a:solidFill>
             <a:prstDash val="solid"/>
           </a:ln>
@@ -2386,14 +2879,14 @@
       </p:sp>
       <p:sp>
         <p:nvSpPr>
-          <p:cNvPr id="7" name="Text 5"/>
-          <p:cNvSpPr/>
-          <p:nvPr/>
-        </p:nvSpPr>
-        <p:spPr>
-          <a:xfrm>
-            <a:off x="7818120" y="1417320"/>
-            <a:ext cx="3246120" cy="3383280"/>
+          <p:cNvPr id="10" name="Text 8"/>
+          <p:cNvSpPr/>
+          <p:nvPr/>
+        </p:nvSpPr>
+        <p:spPr>
+          <a:xfrm>
+            <a:off x="7370064" y="1143000"/>
+            <a:ext cx="3703320" cy="4069080"/>
           </a:xfrm>
           <a:prstGeom prst="rect">
             <a:avLst/>
@@ -2411,55 +2904,83 @@
               <a:buNone/>
             </a:pPr>
             <a:r>
-              <a:rPr lang="en-US" sz="1700" dirty="0">
-                <a:solidFill>
-                  <a:srgbClr val="F4F1E9"/>
-                </a:solidFill>
-              </a:rPr>
-              <a:t>• Agent acts, not just displays</a:t>
-            </a:r>
-            <a:endParaRPr lang="en-US" sz="1700" dirty="0"/>
-          </a:p>
-          <a:p>
-            <a:pPr indent="0" marL="0">
-              <a:buNone/>
-            </a:pPr>
-            <a:r>
-              <a:rPr lang="en-US" sz="1700" dirty="0">
-                <a:solidFill>
-                  <a:srgbClr val="F4F1E9"/>
-                </a:solidFill>
-              </a:rPr>
-              <a:t>• Proof spend can stop after hard-risk signal</a:t>
-            </a:r>
-            <a:endParaRPr lang="en-US" sz="1700" dirty="0"/>
-          </a:p>
-          <a:p>
-            <a:pPr indent="0" marL="0">
-              <a:buNone/>
-            </a:pPr>
-            <a:r>
-              <a:rPr lang="en-US" sz="1700" dirty="0">
-                <a:solidFill>
-                  <a:srgbClr val="F4F1E9"/>
-                </a:solidFill>
-              </a:rPr>
-              <a:t>• Receipts are hash-linked into the decision</a:t>
-            </a:r>
-            <a:endParaRPr lang="en-US" sz="1700" dirty="0"/>
-          </a:p>
-        </p:txBody>
-      </p:sp>
-      <p:sp>
-        <p:nvSpPr>
-          <p:cNvPr id="8" name="Text 6"/>
-          <p:cNvSpPr/>
-          <p:nvPr/>
-        </p:nvSpPr>
-        <p:spPr>
-          <a:xfrm>
-            <a:off x="10716768" y="6080760"/>
-            <a:ext cx="731520" cy="182880"/>
+              <a:rPr lang="en-US" sz="1600" b="1" dirty="0">
+                <a:solidFill>
+                  <a:srgbClr val="F7F3E8"/>
+                </a:solidFill>
+              </a:rPr>
+              <a:t>• Payout intent</a:t>
+            </a:r>
+            <a:endParaRPr lang="en-US" sz="1600" dirty="0"/>
+          </a:p>
+          <a:p>
+            <a:pPr indent="0" marL="0">
+              <a:buNone/>
+            </a:pPr>
+            <a:r>
+              <a:rPr lang="en-US" sz="1600" b="1" dirty="0">
+                <a:solidFill>
+                  <a:srgbClr val="F7F3E8"/>
+                </a:solidFill>
+              </a:rPr>
+              <a:t>• Proof plan</a:t>
+            </a:r>
+            <a:endParaRPr lang="en-US" sz="1600" dirty="0"/>
+          </a:p>
+          <a:p>
+            <a:pPr indent="0" marL="0">
+              <a:buNone/>
+            </a:pPr>
+            <a:r>
+              <a:rPr lang="en-US" sz="1600" b="1" dirty="0">
+                <a:solidFill>
+                  <a:srgbClr val="F7F3E8"/>
+                </a:solidFill>
+              </a:rPr>
+              <a:t>• Paid receipts</a:t>
+            </a:r>
+            <a:endParaRPr lang="en-US" sz="1600" dirty="0"/>
+          </a:p>
+          <a:p>
+            <a:pPr indent="0" marL="0">
+              <a:buNone/>
+            </a:pPr>
+            <a:r>
+              <a:rPr lang="en-US" sz="1600" b="1" dirty="0">
+                <a:solidFill>
+                  <a:srgbClr val="F7F3E8"/>
+                </a:solidFill>
+              </a:rPr>
+              <a:t>• Policy outcome</a:t>
+            </a:r>
+            <a:endParaRPr lang="en-US" sz="1600" dirty="0"/>
+          </a:p>
+          <a:p>
+            <a:pPr indent="0" marL="0">
+              <a:buNone/>
+            </a:pPr>
+            <a:r>
+              <a:rPr lang="en-US" sz="1600" b="1" dirty="0">
+                <a:solidFill>
+                  <a:srgbClr val="F7F3E8"/>
+                </a:solidFill>
+              </a:rPr>
+              <a:t>• Signed packet</a:t>
+            </a:r>
+            <a:endParaRPr lang="en-US" sz="1600" dirty="0"/>
+          </a:p>
+        </p:txBody>
+      </p:sp>
+      <p:sp>
+        <p:nvSpPr>
+          <p:cNvPr id="11" name="Text 9"/>
+          <p:cNvSpPr/>
+          <p:nvPr/>
+        </p:nvSpPr>
+        <p:spPr>
+          <a:xfrm>
+            <a:off x="10643616" y="6236208"/>
+            <a:ext cx="685800" cy="164592"/>
           </a:xfrm>
           <a:prstGeom prst="rect">
             <a:avLst/>
@@ -2480,7 +3001,7 @@
                   <a:srgbClr val="C9B98B"/>
                 </a:solidFill>
               </a:rPr>
-              <a:t>4 / 6</a:t>
+              <a:t>4 / 7</a:t>
             </a:r>
             <a:endParaRPr lang="en-US" sz="900" dirty="0"/>
           </a:p>
@@ -2500,7 +3021,7 @@
     <p:bg>
       <p:bgPr>
         <a:solidFill>
-          <a:srgbClr val="10110F"/>
+          <a:srgbClr val="0B0C0A"/>
         </a:solidFill>
       </p:bgPr>
     </p:bg>
@@ -2526,18 +3047,18 @@
         </p:nvSpPr>
         <p:spPr>
           <a:xfrm>
-            <a:off x="320040" y="320040"/>
-            <a:ext cx="11548872" cy="6217920"/>
+            <a:off x="256032" y="256032"/>
+            <a:ext cx="11686032" cy="6355080"/>
           </a:xfrm>
           <a:prstGeom prst="rect">
             <a:avLst/>
           </a:prstGeom>
           <a:solidFill>
-            <a:srgbClr val="191B17"/>
+            <a:srgbClr val="12140F"/>
           </a:solidFill>
           <a:ln w="12700">
             <a:solidFill>
-              <a:srgbClr val="393A31"/>
+              <a:srgbClr val="3A3D32"/>
             </a:solidFill>
             <a:prstDash val="solid"/>
           </a:ln>
@@ -2551,8 +3072,8 @@
         </p:nvSpPr>
         <p:spPr>
           <a:xfrm>
-            <a:off x="594360" y="640080"/>
-            <a:ext cx="3108960" cy="228600"/>
+            <a:off x="566928" y="621792"/>
+            <a:ext cx="2926080" cy="237744"/>
           </a:xfrm>
           <a:prstGeom prst="rect">
             <a:avLst/>
@@ -2573,7 +3094,7 @@
                   <a:srgbClr val="C9B98B"/>
                 </a:solidFill>
               </a:rPr>
-              <a:t>LIVE DEMO RESULT</a:t>
+              <a:t>05 / TREASURY DECISION</a:t>
             </a:r>
             <a:endParaRPr lang="en-US" sz="1000" dirty="0"/>
           </a:p>
@@ -2587,8 +3108,8 @@
         </p:nvSpPr>
         <p:spPr>
           <a:xfrm>
-            <a:off x="594360" y="1005840"/>
-            <a:ext cx="6537960" cy="1188720"/>
+            <a:off x="566928" y="960120"/>
+            <a:ext cx="6080760" cy="1508760"/>
           </a:xfrm>
           <a:prstGeom prst="rect">
             <a:avLst/>
@@ -2608,10 +3129,10 @@
             <a:r>
               <a:rPr lang="en-US" sz="3100" b="1" dirty="0">
                 <a:solidFill>
-                  <a:srgbClr val="F4F1E9"/>
-                </a:solidFill>
-              </a:rPr>
-              <a:t>$0.39 of proof controls $50,000 of capital exposure</a:t>
+                  <a:srgbClr val="F7F3E8"/>
+                </a:solidFill>
+              </a:rPr>
+              <a:t>Proof quality directly controls how much capital can move.</a:t>
             </a:r>
             <a:endParaRPr lang="en-US" sz="3100" dirty="0"/>
           </a:p>
@@ -2625,8 +3146,8 @@
         </p:nvSpPr>
         <p:spPr>
           <a:xfrm>
-            <a:off x="621792" y="2423160"/>
-            <a:ext cx="5989320" cy="1280160"/>
+            <a:off x="594360" y="2615184"/>
+            <a:ext cx="5650992" cy="1097280"/>
           </a:xfrm>
           <a:prstGeom prst="rect">
             <a:avLst/>
@@ -2644,14 +3165,14 @@
               <a:buNone/>
             </a:pPr>
             <a:r>
-              <a:rPr lang="en-US" sz="1600" dirty="0">
+              <a:rPr lang="en-US" sz="1500" dirty="0">
                 <a:solidFill>
                   <a:srgbClr val="AAA79D"/>
                 </a:solidFill>
               </a:rPr>
-              <a:t>In the high-value scenario, DisburseGuard caps a $75,000 request to $25,000, signs the packet with a production key, and verifies the event chain.</a:t>
-            </a:r>
-            <a:endParaRPr lang="en-US" sz="1600" dirty="0"/>
+              <a:t>In the live scenario, DisburseGuard limits a $75,000 payout to $25,000 and keeps $50,000 controlled until better proof arrives.</a:t>
+            </a:r>
+            <a:endParaRPr lang="en-US" sz="1500" dirty="0"/>
           </a:p>
         </p:txBody>
       </p:sp>
@@ -2663,8 +3184,109 @@
         </p:nvSpPr>
         <p:spPr>
           <a:xfrm>
-            <a:off x="7452360" y="960120"/>
-            <a:ext cx="3886200" cy="4480560"/>
+            <a:off x="603504" y="4251960"/>
+            <a:ext cx="2788920" cy="1298448"/>
+          </a:xfrm>
+          <a:prstGeom prst="rect">
+            <a:avLst/>
+          </a:prstGeom>
+          <a:solidFill>
+            <a:srgbClr val="18231B"/>
+          </a:solidFill>
+          <a:ln w="16510">
+            <a:solidFill>
+              <a:srgbClr val="8BD8A8"/>
+            </a:solidFill>
+            <a:prstDash val="solid"/>
+          </a:ln>
+        </p:spPr>
+      </p:sp>
+      <p:sp>
+        <p:nvSpPr>
+          <p:cNvPr id="7" name="Text 5"/>
+          <p:cNvSpPr/>
+          <p:nvPr/>
+        </p:nvSpPr>
+        <p:spPr>
+          <a:xfrm>
+            <a:off x="841248" y="4434840"/>
+            <a:ext cx="2286000" cy="502920"/>
+          </a:xfrm>
+          <a:prstGeom prst="rect">
+            <a:avLst/>
+          </a:prstGeom>
+          <a:noFill/>
+          <a:ln/>
+        </p:spPr>
+        <p:txBody>
+          <a:bodyPr wrap="square" rtlCol="0" anchor="ctr">
+            <a:normAutofit/>
+          </a:bodyPr>
+          <a:lstStyle/>
+          <a:p>
+            <a:pPr indent="0" marL="0">
+              <a:buNone/>
+            </a:pPr>
+            <a:r>
+              <a:rPr lang="en-US" sz="3000" b="1" dirty="0">
+                <a:solidFill>
+                  <a:srgbClr val="F7F3E8"/>
+                </a:solidFill>
+              </a:rPr>
+              <a:t>$25K</a:t>
+            </a:r>
+            <a:endParaRPr lang="en-US" sz="3000" dirty="0"/>
+          </a:p>
+        </p:txBody>
+      </p:sp>
+      <p:sp>
+        <p:nvSpPr>
+          <p:cNvPr id="8" name="Text 6"/>
+          <p:cNvSpPr/>
+          <p:nvPr/>
+        </p:nvSpPr>
+        <p:spPr>
+          <a:xfrm>
+            <a:off x="841248" y="4956048"/>
+            <a:ext cx="2286000" cy="320040"/>
+          </a:xfrm>
+          <a:prstGeom prst="rect">
+            <a:avLst/>
+          </a:prstGeom>
+          <a:noFill/>
+          <a:ln/>
+        </p:spPr>
+        <p:txBody>
+          <a:bodyPr wrap="square" rtlCol="0" anchor="ctr">
+            <a:normAutofit/>
+          </a:bodyPr>
+          <a:lstStyle/>
+          <a:p>
+            <a:pPr indent="0" marL="0">
+              <a:buNone/>
+            </a:pPr>
+            <a:r>
+              <a:rPr lang="en-US" sz="1050" dirty="0">
+                <a:solidFill>
+                  <a:srgbClr val="AAA79D"/>
+                </a:solidFill>
+              </a:rPr>
+              <a:t>authorized from a $75K request</a:t>
+            </a:r>
+            <a:endParaRPr lang="en-US" sz="1050" dirty="0"/>
+          </a:p>
+        </p:txBody>
+      </p:sp>
+      <p:sp>
+        <p:nvSpPr>
+          <p:cNvPr id="9" name="Shape 7"/>
+          <p:cNvSpPr/>
+          <p:nvPr/>
+        </p:nvSpPr>
+        <p:spPr>
+          <a:xfrm>
+            <a:off x="7022592" y="713232"/>
+            <a:ext cx="4434840" cy="5230368"/>
           </a:xfrm>
           <a:prstGeom prst="rect">
             <a:avLst/>
@@ -2674,7 +3296,7 @@
           </a:solidFill>
           <a:ln w="12700">
             <a:solidFill>
-              <a:srgbClr val="393A31"/>
+              <a:srgbClr val="3A3D32"/>
             </a:solidFill>
             <a:prstDash val="solid"/>
           </a:ln>
@@ -2682,14 +3304,14 @@
       </p:sp>
       <p:sp>
         <p:nvSpPr>
-          <p:cNvPr id="7" name="Text 5"/>
-          <p:cNvSpPr/>
-          <p:nvPr/>
-        </p:nvSpPr>
-        <p:spPr>
-          <a:xfrm>
-            <a:off x="7818120" y="1417320"/>
-            <a:ext cx="3246120" cy="3383280"/>
+          <p:cNvPr id="10" name="Text 8"/>
+          <p:cNvSpPr/>
+          <p:nvPr/>
+        </p:nvSpPr>
+        <p:spPr>
+          <a:xfrm>
+            <a:off x="7370064" y="1143000"/>
+            <a:ext cx="3703320" cy="4069080"/>
           </a:xfrm>
           <a:prstGeom prst="rect">
             <a:avLst/>
@@ -2707,55 +3329,69 @@
               <a:buNone/>
             </a:pPr>
             <a:r>
-              <a:rPr lang="en-US" sz="1700" dirty="0">
-                <a:solidFill>
-                  <a:srgbClr val="F4F1E9"/>
-                </a:solidFill>
-              </a:rPr>
-              <a:t>• Requested: USD 75,000</a:t>
-            </a:r>
-            <a:endParaRPr lang="en-US" sz="1700" dirty="0"/>
-          </a:p>
-          <a:p>
-            <a:pPr indent="0" marL="0">
-              <a:buNone/>
-            </a:pPr>
-            <a:r>
-              <a:rPr lang="en-US" sz="1700" dirty="0">
-                <a:solidFill>
-                  <a:srgbClr val="F4F1E9"/>
-                </a:solidFill>
-              </a:rPr>
-              <a:t>• Authorized: USD 25,000</a:t>
-            </a:r>
-            <a:endParaRPr lang="en-US" sz="1700" dirty="0"/>
-          </a:p>
-          <a:p>
-            <a:pPr indent="0" marL="0">
-              <a:buNone/>
-            </a:pPr>
-            <a:r>
-              <a:rPr lang="en-US" sz="1700" dirty="0">
-                <a:solidFill>
-                  <a:srgbClr val="F4F1E9"/>
-                </a:solidFill>
-              </a:rPr>
-              <a:t>• Ledger: postgres-drizzle valid chain</a:t>
-            </a:r>
-            <a:endParaRPr lang="en-US" sz="1700" dirty="0"/>
-          </a:p>
-        </p:txBody>
-      </p:sp>
-      <p:sp>
-        <p:nvSpPr>
-          <p:cNvPr id="8" name="Text 6"/>
-          <p:cNvSpPr/>
-          <p:nvPr/>
-        </p:nvSpPr>
-        <p:spPr>
-          <a:xfrm>
-            <a:off x="10716768" y="6080760"/>
-            <a:ext cx="731520" cy="182880"/>
+              <a:rPr lang="en-US" sz="1600" b="1" dirty="0">
+                <a:solidFill>
+                  <a:srgbClr val="F7F3E8"/>
+                </a:solidFill>
+              </a:rPr>
+              <a:t>• CLEAR: verified release</a:t>
+            </a:r>
+            <a:endParaRPr lang="en-US" sz="1600" dirty="0"/>
+          </a:p>
+          <a:p>
+            <a:pPr indent="0" marL="0">
+              <a:buNone/>
+            </a:pPr>
+            <a:r>
+              <a:rPr lang="en-US" sz="1600" b="1" dirty="0">
+                <a:solidFill>
+                  <a:srgbClr val="F7F3E8"/>
+                </a:solidFill>
+              </a:rPr>
+              <a:t>• LIMIT: capped payout</a:t>
+            </a:r>
+            <a:endParaRPr lang="en-US" sz="1600" dirty="0"/>
+          </a:p>
+          <a:p>
+            <a:pPr indent="0" marL="0">
+              <a:buNone/>
+            </a:pPr>
+            <a:r>
+              <a:rPr lang="en-US" sz="1600" b="1" dirty="0">
+                <a:solidFill>
+                  <a:srgbClr val="F7F3E8"/>
+                </a:solidFill>
+              </a:rPr>
+              <a:t>• REVIEW: human queue</a:t>
+            </a:r>
+            <a:endParaRPr lang="en-US" sz="1600" dirty="0"/>
+          </a:p>
+          <a:p>
+            <a:pPr indent="0" marL="0">
+              <a:buNone/>
+            </a:pPr>
+            <a:r>
+              <a:rPr lang="en-US" sz="1600" b="1" dirty="0">
+                <a:solidFill>
+                  <a:srgbClr val="F7F3E8"/>
+                </a:solidFill>
+              </a:rPr>
+              <a:t>• BLOCK: hard stop</a:t>
+            </a:r>
+            <a:endParaRPr lang="en-US" sz="1600" dirty="0"/>
+          </a:p>
+        </p:txBody>
+      </p:sp>
+      <p:sp>
+        <p:nvSpPr>
+          <p:cNvPr id="11" name="Text 9"/>
+          <p:cNvSpPr/>
+          <p:nvPr/>
+        </p:nvSpPr>
+        <p:spPr>
+          <a:xfrm>
+            <a:off x="10643616" y="6236208"/>
+            <a:ext cx="685800" cy="164592"/>
           </a:xfrm>
           <a:prstGeom prst="rect">
             <a:avLst/>
@@ -2776,7 +3412,7 @@
                   <a:srgbClr val="C9B98B"/>
                 </a:solidFill>
               </a:rPr>
-              <a:t>5 / 6</a:t>
+              <a:t>5 / 7</a:t>
             </a:r>
             <a:endParaRPr lang="en-US" sz="900" dirty="0"/>
           </a:p>
@@ -2796,7 +3432,7 @@
     <p:bg>
       <p:bgPr>
         <a:solidFill>
-          <a:srgbClr val="10110F"/>
+          <a:srgbClr val="0B0C0A"/>
         </a:solidFill>
       </p:bgPr>
     </p:bg>
@@ -2822,18 +3458,18 @@
         </p:nvSpPr>
         <p:spPr>
           <a:xfrm>
-            <a:off x="320040" y="320040"/>
-            <a:ext cx="11548872" cy="6217920"/>
+            <a:off x="256032" y="256032"/>
+            <a:ext cx="11686032" cy="6355080"/>
           </a:xfrm>
           <a:prstGeom prst="rect">
             <a:avLst/>
           </a:prstGeom>
           <a:solidFill>
-            <a:srgbClr val="191B17"/>
+            <a:srgbClr val="12140F"/>
           </a:solidFill>
           <a:ln w="12700">
             <a:solidFill>
-              <a:srgbClr val="393A31"/>
+              <a:srgbClr val="3A3D32"/>
             </a:solidFill>
             <a:prstDash val="solid"/>
           </a:ln>
@@ -2847,8 +3483,8 @@
         </p:nvSpPr>
         <p:spPr>
           <a:xfrm>
-            <a:off x="594360" y="640080"/>
-            <a:ext cx="3108960" cy="228600"/>
+            <a:off x="566928" y="621792"/>
+            <a:ext cx="2926080" cy="237744"/>
           </a:xfrm>
           <a:prstGeom prst="rect">
             <a:avLst/>
@@ -2869,7 +3505,7 @@
                   <a:srgbClr val="C9B98B"/>
                 </a:solidFill>
               </a:rPr>
-              <a:t>WHY IT WINS</a:t>
+              <a:t>06 / VERIFICATION</a:t>
             </a:r>
             <a:endParaRPr lang="en-US" sz="1000" dirty="0"/>
           </a:p>
@@ -2883,8 +3519,8 @@
         </p:nvSpPr>
         <p:spPr>
           <a:xfrm>
-            <a:off x="594360" y="1005840"/>
-            <a:ext cx="6537960" cy="1188720"/>
+            <a:off x="566928" y="960120"/>
+            <a:ext cx="6080760" cy="1508760"/>
           </a:xfrm>
           <a:prstGeom prst="rect">
             <a:avLst/>
@@ -2904,10 +3540,10 @@
             <a:r>
               <a:rPr lang="en-US" sz="3100" b="1" dirty="0">
                 <a:solidFill>
-                  <a:srgbClr val="F4F1E9"/>
-                </a:solidFill>
-              </a:rPr>
-              <a:t>A protocol-shaped product, not another dashboard</a:t>
+                  <a:srgbClr val="F7F3E8"/>
+                </a:solidFill>
+              </a:rPr>
+              <a:t>Every clearance becomes independently verifiable.</a:t>
             </a:r>
             <a:endParaRPr lang="en-US" sz="3100" dirty="0"/>
           </a:p>
@@ -2921,8 +3557,8 @@
         </p:nvSpPr>
         <p:spPr>
           <a:xfrm>
-            <a:off x="621792" y="2423160"/>
-            <a:ext cx="5989320" cy="1280160"/>
+            <a:off x="594360" y="2615184"/>
+            <a:ext cx="5650992" cy="1097280"/>
           </a:xfrm>
           <a:prstGeom prst="rect">
             <a:avLst/>
@@ -2940,14 +3576,14 @@
               <a:buNone/>
             </a:pPr>
             <a:r>
-              <a:rPr lang="en-US" sz="1600" dirty="0">
+              <a:rPr lang="en-US" sz="1500" dirty="0">
                 <a:solidFill>
                   <a:srgbClr val="AAA79D"/>
                 </a:solidFill>
               </a:rPr>
-              <a:t>DisburseGuard creates an economic enforcement loop for AI finance: spend cents on paid proof before releasing thousands in company funds.</a:t>
-            </a:r>
-            <a:endParaRPr lang="en-US" sz="1600" dirty="0"/>
+              <a:t>The ClearancePacket contains proof hashes, policy version, expiry, rationale, public key, and signature. The ledger chains every event hash.</a:t>
+            </a:r>
+            <a:endParaRPr lang="en-US" sz="1500" dirty="0"/>
           </a:p>
         </p:txBody>
       </p:sp>
@@ -2959,8 +3595,109 @@
         </p:nvSpPr>
         <p:spPr>
           <a:xfrm>
-            <a:off x="7452360" y="960120"/>
-            <a:ext cx="3886200" cy="4480560"/>
+            <a:off x="603504" y="4251960"/>
+            <a:ext cx="2788920" cy="1298448"/>
+          </a:xfrm>
+          <a:prstGeom prst="rect">
+            <a:avLst/>
+          </a:prstGeom>
+          <a:solidFill>
+            <a:srgbClr val="18231B"/>
+          </a:solidFill>
+          <a:ln w="16510">
+            <a:solidFill>
+              <a:srgbClr val="8BD8A8"/>
+            </a:solidFill>
+            <a:prstDash val="solid"/>
+          </a:ln>
+        </p:spPr>
+      </p:sp>
+      <p:sp>
+        <p:nvSpPr>
+          <p:cNvPr id="7" name="Text 5"/>
+          <p:cNvSpPr/>
+          <p:nvPr/>
+        </p:nvSpPr>
+        <p:spPr>
+          <a:xfrm>
+            <a:off x="841248" y="4434840"/>
+            <a:ext cx="2286000" cy="502920"/>
+          </a:xfrm>
+          <a:prstGeom prst="rect">
+            <a:avLst/>
+          </a:prstGeom>
+          <a:noFill/>
+          <a:ln/>
+        </p:spPr>
+        <p:txBody>
+          <a:bodyPr wrap="square" rtlCol="0" anchor="ctr">
+            <a:normAutofit/>
+          </a:bodyPr>
+          <a:lstStyle/>
+          <a:p>
+            <a:pPr indent="0" marL="0">
+              <a:buNone/>
+            </a:pPr>
+            <a:r>
+              <a:rPr lang="en-US" sz="3000" b="1" dirty="0">
+                <a:solidFill>
+                  <a:srgbClr val="F7F3E8"/>
+                </a:solidFill>
+              </a:rPr>
+              <a:t>valid</a:t>
+            </a:r>
+            <a:endParaRPr lang="en-US" sz="3000" dirty="0"/>
+          </a:p>
+        </p:txBody>
+      </p:sp>
+      <p:sp>
+        <p:nvSpPr>
+          <p:cNvPr id="8" name="Text 6"/>
+          <p:cNvSpPr/>
+          <p:nvPr/>
+        </p:nvSpPr>
+        <p:spPr>
+          <a:xfrm>
+            <a:off x="841248" y="4956048"/>
+            <a:ext cx="2286000" cy="320040"/>
+          </a:xfrm>
+          <a:prstGeom prst="rect">
+            <a:avLst/>
+          </a:prstGeom>
+          <a:noFill/>
+          <a:ln/>
+        </p:spPr>
+        <p:txBody>
+          <a:bodyPr wrap="square" rtlCol="0" anchor="ctr">
+            <a:normAutofit/>
+          </a:bodyPr>
+          <a:lstStyle/>
+          <a:p>
+            <a:pPr indent="0" marL="0">
+              <a:buNone/>
+            </a:pPr>
+            <a:r>
+              <a:rPr lang="en-US" sz="1050" dirty="0">
+                <a:solidFill>
+                  <a:srgbClr val="AAA79D"/>
+                </a:solidFill>
+              </a:rPr>
+              <a:t>packet signature and event chain</a:t>
+            </a:r>
+            <a:endParaRPr lang="en-US" sz="1050" dirty="0"/>
+          </a:p>
+        </p:txBody>
+      </p:sp>
+      <p:sp>
+        <p:nvSpPr>
+          <p:cNvPr id="9" name="Shape 7"/>
+          <p:cNvSpPr/>
+          <p:nvPr/>
+        </p:nvSpPr>
+        <p:spPr>
+          <a:xfrm>
+            <a:off x="7022592" y="713232"/>
+            <a:ext cx="4434840" cy="5230368"/>
           </a:xfrm>
           <a:prstGeom prst="rect">
             <a:avLst/>
@@ -2970,7 +3707,7 @@
           </a:solidFill>
           <a:ln w="12700">
             <a:solidFill>
-              <a:srgbClr val="393A31"/>
+              <a:srgbClr val="3A3D32"/>
             </a:solidFill>
             <a:prstDash val="solid"/>
           </a:ln>
@@ -2978,14 +3715,14 @@
       </p:sp>
       <p:sp>
         <p:nvSpPr>
-          <p:cNvPr id="7" name="Text 5"/>
-          <p:cNvSpPr/>
-          <p:nvPr/>
-        </p:nvSpPr>
-        <p:spPr>
-          <a:xfrm>
-            <a:off x="7818120" y="1417320"/>
-            <a:ext cx="3246120" cy="3383280"/>
+          <p:cNvPr id="10" name="Text 8"/>
+          <p:cNvSpPr/>
+          <p:nvPr/>
+        </p:nvSpPr>
+        <p:spPr>
+          <a:xfrm>
+            <a:off x="7370064" y="1143000"/>
+            <a:ext cx="3703320" cy="4069080"/>
           </a:xfrm>
           <a:prstGeom prst="rect">
             <a:avLst/>
@@ -3003,42 +3740,310 @@
               <a:buNone/>
             </a:pPr>
             <a:r>
-              <a:rPr lang="en-US" sz="1700" dirty="0">
-                <a:solidFill>
-                  <a:srgbClr val="F4F1E9"/>
-                </a:solidFill>
-              </a:rPr>
-              <a:t>• Strong x402 fit</a:t>
-            </a:r>
-            <a:endParaRPr lang="en-US" sz="1700" dirty="0"/>
-          </a:p>
-          <a:p>
-            <a:pPr indent="0" marL="0">
-              <a:buNone/>
-            </a:pPr>
-            <a:r>
-              <a:rPr lang="en-US" sz="1700" dirty="0">
-                <a:solidFill>
-                  <a:srgbClr val="F4F1E9"/>
-                </a:solidFill>
-              </a:rPr>
-              <a:t>• B2B FinOps and compliance use case</a:t>
-            </a:r>
-            <a:endParaRPr lang="en-US" sz="1700" dirty="0"/>
-          </a:p>
-          <a:p>
-            <a:pPr indent="0" marL="0">
-              <a:buNone/>
-            </a:pPr>
-            <a:r>
-              <a:rPr lang="en-US" sz="1700" dirty="0">
-                <a:solidFill>
-                  <a:srgbClr val="F4F1E9"/>
-                </a:solidFill>
-              </a:rPr>
-              <a:t>• Public Vultr deployment with verifiable APIs</a:t>
-            </a:r>
-            <a:endParaRPr lang="en-US" sz="1700" dirty="0"/>
+              <a:rPr lang="en-US" sz="1600" b="1" dirty="0">
+                <a:solidFill>
+                  <a:srgbClr val="F7F3E8"/>
+                </a:solidFill>
+              </a:rPr>
+              <a:t>• production-key signature</a:t>
+            </a:r>
+            <a:endParaRPr lang="en-US" sz="1600" dirty="0"/>
+          </a:p>
+          <a:p>
+            <a:pPr indent="0" marL="0">
+              <a:buNone/>
+            </a:pPr>
+            <a:r>
+              <a:rPr lang="en-US" sz="1600" b="1" dirty="0">
+                <a:solidFill>
+                  <a:srgbClr val="F7F3E8"/>
+                </a:solidFill>
+              </a:rPr>
+              <a:t>• append-only event hashes</a:t>
+            </a:r>
+            <a:endParaRPr lang="en-US" sz="1600" dirty="0"/>
+          </a:p>
+          <a:p>
+            <a:pPr indent="0" marL="0">
+              <a:buNone/>
+            </a:pPr>
+            <a:r>
+              <a:rPr lang="en-US" sz="1600" b="1" dirty="0">
+                <a:solidFill>
+                  <a:srgbClr val="F7F3E8"/>
+                </a:solidFill>
+              </a:rPr>
+              <a:t>• /api/clearance/:id/verify</a:t>
+            </a:r>
+            <a:endParaRPr lang="en-US" sz="1600" dirty="0"/>
+          </a:p>
+        </p:txBody>
+      </p:sp>
+      <p:sp>
+        <p:nvSpPr>
+          <p:cNvPr id="11" name="Text 9"/>
+          <p:cNvSpPr/>
+          <p:nvPr/>
+        </p:nvSpPr>
+        <p:spPr>
+          <a:xfrm>
+            <a:off x="10643616" y="6236208"/>
+            <a:ext cx="685800" cy="164592"/>
+          </a:xfrm>
+          <a:prstGeom prst="rect">
+            <a:avLst/>
+          </a:prstGeom>
+          <a:noFill/>
+          <a:ln/>
+        </p:spPr>
+        <p:txBody>
+          <a:bodyPr wrap="square" rtlCol="0" anchor="ctr"/>
+          <a:lstStyle/>
+          <a:p>
+            <a:pPr algn="r" indent="0" marL="0">
+              <a:buNone/>
+            </a:pPr>
+            <a:r>
+              <a:rPr lang="en-US" sz="900" dirty="0">
+                <a:solidFill>
+                  <a:srgbClr val="C9B98B"/>
+                </a:solidFill>
+              </a:rPr>
+              <a:t>6 / 7</a:t>
+            </a:r>
+            <a:endParaRPr lang="en-US" sz="900" dirty="0"/>
+          </a:p>
+        </p:txBody>
+      </p:sp>
+    </p:spTree>
+  </p:cSld>
+  <p:clrMapOvr>
+    <a:masterClrMapping/>
+  </p:clrMapOvr>
+</p:sld>
+</file>
+
+<file path=ppt/slides/slide7.xml><?xml version="1.0" encoding="utf-8"?>
+<p:sld xmlns:a="http://schemas.openxmlformats.org/drawingml/2006/main" xmlns:r="http://schemas.openxmlformats.org/officeDocument/2006/relationships" xmlns:p="http://schemas.openxmlformats.org/presentationml/2006/main">
+  <p:cSld name="Slide 7">
+    <p:bg>
+      <p:bgPr>
+        <a:solidFill>
+          <a:srgbClr val="0B0C0A"/>
+        </a:solidFill>
+      </p:bgPr>
+    </p:bg>
+    <p:spTree>
+      <p:nvGrpSpPr>
+        <p:cNvPr id="1" name=""/>
+        <p:cNvGrpSpPr/>
+        <p:nvPr/>
+      </p:nvGrpSpPr>
+      <p:grpSpPr>
+        <a:xfrm>
+          <a:off x="0" y="0"/>
+          <a:ext cx="0" cy="0"/>
+          <a:chOff x="0" y="0"/>
+          <a:chExt cx="0" cy="0"/>
+        </a:xfrm>
+      </p:grpSpPr>
+      <p:sp>
+        <p:nvSpPr>
+          <p:cNvPr id="2" name="Shape 0"/>
+          <p:cNvSpPr/>
+          <p:nvPr/>
+        </p:nvSpPr>
+        <p:spPr>
+          <a:xfrm>
+            <a:off x="256032" y="256032"/>
+            <a:ext cx="11686032" cy="6355080"/>
+          </a:xfrm>
+          <a:prstGeom prst="rect">
+            <a:avLst/>
+          </a:prstGeom>
+          <a:solidFill>
+            <a:srgbClr val="12140F"/>
+          </a:solidFill>
+          <a:ln w="12700">
+            <a:solidFill>
+              <a:srgbClr val="3A3D32"/>
+            </a:solidFill>
+            <a:prstDash val="solid"/>
+          </a:ln>
+        </p:spPr>
+      </p:sp>
+      <p:sp>
+        <p:nvSpPr>
+          <p:cNvPr id="3" name="Text 1"/>
+          <p:cNvSpPr/>
+          <p:nvPr/>
+        </p:nvSpPr>
+        <p:spPr>
+          <a:xfrm>
+            <a:off x="566928" y="621792"/>
+            <a:ext cx="2926080" cy="237744"/>
+          </a:xfrm>
+          <a:prstGeom prst="rect">
+            <a:avLst/>
+          </a:prstGeom>
+          <a:noFill/>
+          <a:ln/>
+        </p:spPr>
+        <p:txBody>
+          <a:bodyPr wrap="square" rtlCol="0" anchor="ctr"/>
+          <a:lstStyle/>
+          <a:p>
+            <a:pPr indent="0" marL="0">
+              <a:buNone/>
+            </a:pPr>
+            <a:r>
+              <a:rPr lang="en-US" sz="1000" b="1" dirty="0">
+                <a:solidFill>
+                  <a:srgbClr val="C9B98B"/>
+                </a:solidFill>
+              </a:rPr>
+              <a:t>07 / WHY IT WINS</a:t>
+            </a:r>
+            <a:endParaRPr lang="en-US" sz="1000" dirty="0"/>
+          </a:p>
+        </p:txBody>
+      </p:sp>
+      <p:sp>
+        <p:nvSpPr>
+          <p:cNvPr id="4" name="Text 2"/>
+          <p:cNvSpPr/>
+          <p:nvPr/>
+        </p:nvSpPr>
+        <p:spPr>
+          <a:xfrm>
+            <a:off x="566928" y="960120"/>
+            <a:ext cx="6080760" cy="1508760"/>
+          </a:xfrm>
+          <a:prstGeom prst="rect">
+            <a:avLst/>
+          </a:prstGeom>
+          <a:noFill/>
+          <a:ln/>
+        </p:spPr>
+        <p:txBody>
+          <a:bodyPr wrap="square" rtlCol="0" anchor="ctr">
+            <a:normAutofit/>
+          </a:bodyPr>
+          <a:lstStyle/>
+          <a:p>
+            <a:pPr indent="0" marL="0">
+              <a:buNone/>
+            </a:pPr>
+            <a:r>
+              <a:rPr lang="en-US" sz="3100" b="1" dirty="0">
+                <a:solidFill>
+                  <a:srgbClr val="F7F3E8"/>
+                </a:solidFill>
+              </a:rPr>
+              <a:t>A protocol-shaped product for autonomous finance.</a:t>
+            </a:r>
+            <a:endParaRPr lang="en-US" sz="3100" dirty="0"/>
+          </a:p>
+        </p:txBody>
+      </p:sp>
+      <p:sp>
+        <p:nvSpPr>
+          <p:cNvPr id="5" name="Text 3"/>
+          <p:cNvSpPr/>
+          <p:nvPr/>
+        </p:nvSpPr>
+        <p:spPr>
+          <a:xfrm>
+            <a:off x="594360" y="2615184"/>
+            <a:ext cx="5650992" cy="1097280"/>
+          </a:xfrm>
+          <a:prstGeom prst="rect">
+            <a:avLst/>
+          </a:prstGeom>
+          <a:noFill/>
+          <a:ln/>
+        </p:spPr>
+        <p:txBody>
+          <a:bodyPr wrap="square" rtlCol="0" anchor="ctr">
+            <a:normAutofit/>
+          </a:bodyPr>
+          <a:lstStyle/>
+          <a:p>
+            <a:pPr indent="0" marL="0">
+              <a:buNone/>
+            </a:pPr>
+            <a:r>
+              <a:rPr lang="en-US" sz="1500" dirty="0">
+                <a:solidFill>
+                  <a:srgbClr val="AAA79D"/>
+                </a:solidFill>
+              </a:rPr>
+              <a:t>DisburseGuard aligns directly with x402 payments, Gemini, Vultr, B2B FinOps, compliance, and agentic workflows.</a:t>
+            </a:r>
+            <a:endParaRPr lang="en-US" sz="1500" dirty="0"/>
+          </a:p>
+        </p:txBody>
+      </p:sp>
+      <p:sp>
+        <p:nvSpPr>
+          <p:cNvPr id="6" name="Shape 4"/>
+          <p:cNvSpPr/>
+          <p:nvPr/>
+        </p:nvSpPr>
+        <p:spPr>
+          <a:xfrm>
+            <a:off x="603504" y="4251960"/>
+            <a:ext cx="2788920" cy="1298448"/>
+          </a:xfrm>
+          <a:prstGeom prst="rect">
+            <a:avLst/>
+          </a:prstGeom>
+          <a:solidFill>
+            <a:srgbClr val="18231B"/>
+          </a:solidFill>
+          <a:ln w="16510">
+            <a:solidFill>
+              <a:srgbClr val="8BD8A8"/>
+            </a:solidFill>
+            <a:prstDash val="solid"/>
+          </a:ln>
+        </p:spPr>
+      </p:sp>
+      <p:sp>
+        <p:nvSpPr>
+          <p:cNvPr id="7" name="Text 5"/>
+          <p:cNvSpPr/>
+          <p:nvPr/>
+        </p:nvSpPr>
+        <p:spPr>
+          <a:xfrm>
+            <a:off x="841248" y="4434840"/>
+            <a:ext cx="2286000" cy="502920"/>
+          </a:xfrm>
+          <a:prstGeom prst="rect">
+            <a:avLst/>
+          </a:prstGeom>
+          <a:noFill/>
+          <a:ln/>
+        </p:spPr>
+        <p:txBody>
+          <a:bodyPr wrap="square" rtlCol="0" anchor="ctr">
+            <a:normAutofit/>
+          </a:bodyPr>
+          <a:lstStyle/>
+          <a:p>
+            <a:pPr indent="0" marL="0">
+              <a:buNone/>
+            </a:pPr>
+            <a:r>
+              <a:rPr lang="en-US" sz="3000" b="1" dirty="0">
+                <a:solidFill>
+                  <a:srgbClr val="F7F3E8"/>
+                </a:solidFill>
+              </a:rPr>
+              <a:t>live</a:t>
+            </a:r>
+            <a:endParaRPr lang="en-US" sz="3000" dirty="0"/>
           </a:p>
         </p:txBody>
       </p:sp>
@@ -3050,8 +4055,151 @@
         </p:nvSpPr>
         <p:spPr>
           <a:xfrm>
-            <a:off x="10716768" y="6080760"/>
-            <a:ext cx="731520" cy="182880"/>
+            <a:off x="841248" y="4956048"/>
+            <a:ext cx="2286000" cy="320040"/>
+          </a:xfrm>
+          <a:prstGeom prst="rect">
+            <a:avLst/>
+          </a:prstGeom>
+          <a:noFill/>
+          <a:ln/>
+        </p:spPr>
+        <p:txBody>
+          <a:bodyPr wrap="square" rtlCol="0" anchor="ctr">
+            <a:normAutofit/>
+          </a:bodyPr>
+          <a:lstStyle/>
+          <a:p>
+            <a:pPr indent="0" marL="0">
+              <a:buNone/>
+            </a:pPr>
+            <a:r>
+              <a:rPr lang="en-US" sz="1050" dirty="0">
+                <a:solidFill>
+                  <a:srgbClr val="AAA79D"/>
+                </a:solidFill>
+              </a:rPr>
+              <a:t>public Vultr deployment</a:t>
+            </a:r>
+            <a:endParaRPr lang="en-US" sz="1050" dirty="0"/>
+          </a:p>
+        </p:txBody>
+      </p:sp>
+      <p:sp>
+        <p:nvSpPr>
+          <p:cNvPr id="9" name="Shape 7"/>
+          <p:cNvSpPr/>
+          <p:nvPr/>
+        </p:nvSpPr>
+        <p:spPr>
+          <a:xfrm>
+            <a:off x="7022592" y="713232"/>
+            <a:ext cx="4434840" cy="5230368"/>
+          </a:xfrm>
+          <a:prstGeom prst="rect">
+            <a:avLst/>
+          </a:prstGeom>
+          <a:solidFill>
+            <a:srgbClr val="20231D"/>
+          </a:solidFill>
+          <a:ln w="12700">
+            <a:solidFill>
+              <a:srgbClr val="3A3D32"/>
+            </a:solidFill>
+            <a:prstDash val="solid"/>
+          </a:ln>
+        </p:spPr>
+      </p:sp>
+      <p:sp>
+        <p:nvSpPr>
+          <p:cNvPr id="10" name="Text 8"/>
+          <p:cNvSpPr/>
+          <p:nvPr/>
+        </p:nvSpPr>
+        <p:spPr>
+          <a:xfrm>
+            <a:off x="7370064" y="1143000"/>
+            <a:ext cx="3703320" cy="4069080"/>
+          </a:xfrm>
+          <a:prstGeom prst="rect">
+            <a:avLst/>
+          </a:prstGeom>
+          <a:noFill/>
+          <a:ln/>
+        </p:spPr>
+        <p:txBody>
+          <a:bodyPr wrap="square" rtlCol="0" anchor="ctr">
+            <a:normAutofit/>
+          </a:bodyPr>
+          <a:lstStyle/>
+          <a:p>
+            <a:pPr indent="0" marL="0">
+              <a:buNone/>
+            </a:pPr>
+            <a:r>
+              <a:rPr lang="en-US" sz="1600" b="1" dirty="0">
+                <a:solidFill>
+                  <a:srgbClr val="F7F3E8"/>
+                </a:solidFill>
+              </a:rPr>
+              <a:t>• x402: paid proof primitive</a:t>
+            </a:r>
+            <a:endParaRPr lang="en-US" sz="1600" dirty="0"/>
+          </a:p>
+          <a:p>
+            <a:pPr indent="0" marL="0">
+              <a:buNone/>
+            </a:pPr>
+            <a:r>
+              <a:rPr lang="en-US" sz="1600" b="1" dirty="0">
+                <a:solidFill>
+                  <a:srgbClr val="F7F3E8"/>
+                </a:solidFill>
+              </a:rPr>
+              <a:t>• Gemini: extraction agent</a:t>
+            </a:r>
+            <a:endParaRPr lang="en-US" sz="1600" dirty="0"/>
+          </a:p>
+          <a:p>
+            <a:pPr indent="0" marL="0">
+              <a:buNone/>
+            </a:pPr>
+            <a:r>
+              <a:rPr lang="en-US" sz="1600" b="1" dirty="0">
+                <a:solidFill>
+                  <a:srgbClr val="F7F3E8"/>
+                </a:solidFill>
+              </a:rPr>
+              <a:t>• Vultr: deployed ledger</a:t>
+            </a:r>
+            <a:endParaRPr lang="en-US" sz="1600" dirty="0"/>
+          </a:p>
+          <a:p>
+            <a:pPr indent="0" marL="0">
+              <a:buNone/>
+            </a:pPr>
+            <a:r>
+              <a:rPr lang="en-US" sz="1600" b="1" dirty="0">
+                <a:solidFill>
+                  <a:srgbClr val="F7F3E8"/>
+                </a:solidFill>
+              </a:rPr>
+              <a:t>• FinOps: payout control</a:t>
+            </a:r>
+            <a:endParaRPr lang="en-US" sz="1600" dirty="0"/>
+          </a:p>
+        </p:txBody>
+      </p:sp>
+      <p:sp>
+        <p:nvSpPr>
+          <p:cNvPr id="11" name="Text 9"/>
+          <p:cNvSpPr/>
+          <p:nvPr/>
+        </p:nvSpPr>
+        <p:spPr>
+          <a:xfrm>
+            <a:off x="10643616" y="6236208"/>
+            <a:ext cx="685800" cy="164592"/>
           </a:xfrm>
           <a:prstGeom prst="rect">
             <a:avLst/>
@@ -3072,7 +4220,7 @@
                   <a:srgbClr val="C9B98B"/>
                 </a:solidFill>
               </a:rPr>
-              <a:t>6 / 6</a:t>
+              <a:t>7 / 7</a:t>
             </a:r>
             <a:endParaRPr lang="en-US" sz="900" dirty="0"/>
           </a:p>

</xml_diff>

<commit_message>
Redesign submission deck and cover
</commit_message>
<xml_diff>
--- a/artifacts/submission/disburseguard-slides.pptx
+++ b/artifacts/submission/disburseguard-slides.pptx
@@ -1391,7 +1391,7 @@
     <p:bg>
       <p:bgPr>
         <a:solidFill>
-          <a:srgbClr val="0B0C0A"/>
+          <a:srgbClr val="F7F2E8"/>
         </a:solidFill>
       </p:bgPr>
     </p:bg>
@@ -1409,371 +1409,30 @@
           <a:chExt cx="0" cy="0"/>
         </a:xfrm>
       </p:grpSpPr>
-      <p:sp>
-        <p:nvSpPr>
-          <p:cNvPr id="2" name="Shape 0"/>
-          <p:cNvSpPr/>
-          <p:nvPr/>
-        </p:nvSpPr>
-        <p:spPr>
-          <a:xfrm>
-            <a:off x="256032" y="256032"/>
-            <a:ext cx="11686032" cy="6355080"/>
-          </a:xfrm>
-          <a:prstGeom prst="rect">
-            <a:avLst/>
-          </a:prstGeom>
-          <a:solidFill>
-            <a:srgbClr val="12140F"/>
-          </a:solidFill>
-          <a:ln w="12700">
-            <a:solidFill>
-              <a:srgbClr val="3A3D32"/>
-            </a:solidFill>
-            <a:prstDash val="solid"/>
-          </a:ln>
-        </p:spPr>
-      </p:sp>
-      <p:sp>
-        <p:nvSpPr>
-          <p:cNvPr id="3" name="Text 1"/>
-          <p:cNvSpPr/>
-          <p:nvPr/>
-        </p:nvSpPr>
-        <p:spPr>
-          <a:xfrm>
-            <a:off x="566928" y="621792"/>
-            <a:ext cx="2926080" cy="237744"/>
-          </a:xfrm>
-          <a:prstGeom prst="rect">
-            <a:avLst/>
-          </a:prstGeom>
-          <a:noFill/>
-          <a:ln/>
-        </p:spPr>
-        <p:txBody>
-          <a:bodyPr wrap="square" rtlCol="0" anchor="ctr"/>
-          <a:lstStyle/>
-          <a:p>
-            <a:pPr indent="0" marL="0">
-              <a:buNone/>
-            </a:pPr>
-            <a:r>
-              <a:rPr lang="en-US" sz="1000" b="1" dirty="0">
-                <a:solidFill>
-                  <a:srgbClr val="C9B98B"/>
-                </a:solidFill>
-              </a:rPr>
-              <a:t>01 / THESIS</a:t>
-            </a:r>
-            <a:endParaRPr lang="en-US" sz="1000" dirty="0"/>
-          </a:p>
-        </p:txBody>
-      </p:sp>
-      <p:sp>
-        <p:nvSpPr>
-          <p:cNvPr id="4" name="Text 2"/>
-          <p:cNvSpPr/>
-          <p:nvPr/>
-        </p:nvSpPr>
-        <p:spPr>
-          <a:xfrm>
-            <a:off x="566928" y="960120"/>
-            <a:ext cx="6080760" cy="1508760"/>
-          </a:xfrm>
-          <a:prstGeom prst="rect">
-            <a:avLst/>
-          </a:prstGeom>
-          <a:noFill/>
-          <a:ln/>
-        </p:spPr>
-        <p:txBody>
-          <a:bodyPr wrap="square" rtlCol="0" anchor="ctr">
-            <a:normAutofit/>
-          </a:bodyPr>
-          <a:lstStyle/>
-          <a:p>
-            <a:pPr indent="0" marL="0">
-              <a:buNone/>
-            </a:pPr>
-            <a:r>
-              <a:rPr lang="en-US" sz="3800" b="1" dirty="0">
-                <a:solidFill>
-                  <a:srgbClr val="F7F3E8"/>
-                </a:solidFill>
-              </a:rPr>
-              <a:t>No proof. No payout.</a:t>
-            </a:r>
-            <a:endParaRPr lang="en-US" sz="3800" dirty="0"/>
-          </a:p>
-        </p:txBody>
-      </p:sp>
-      <p:sp>
-        <p:nvSpPr>
-          <p:cNvPr id="5" name="Text 3"/>
-          <p:cNvSpPr/>
-          <p:nvPr/>
-        </p:nvSpPr>
-        <p:spPr>
-          <a:xfrm>
-            <a:off x="594360" y="2615184"/>
-            <a:ext cx="5650992" cy="1097280"/>
-          </a:xfrm>
-          <a:prstGeom prst="rect">
-            <a:avLst/>
-          </a:prstGeom>
-          <a:noFill/>
-          <a:ln/>
-        </p:spPr>
-        <p:txBody>
-          <a:bodyPr wrap="square" rtlCol="0" anchor="ctr">
-            <a:normAutofit/>
-          </a:bodyPr>
-          <a:lstStyle/>
-          <a:p>
-            <a:pPr indent="0" marL="0">
-              <a:buNone/>
-            </a:pPr>
-            <a:r>
-              <a:rPr lang="en-US" sz="1500" dirty="0">
-                <a:solidFill>
-                  <a:srgbClr val="AAA79D"/>
-                </a:solidFill>
-              </a:rPr>
-              <a:t>DisburseGuard is a proof-paid treasury firewall for AI payout agents. The agent must buy, verify, sign, and ledger proof before company money can move.</a:t>
-            </a:r>
-            <a:endParaRPr lang="en-US" sz="1500" dirty="0"/>
-          </a:p>
-        </p:txBody>
-      </p:sp>
-      <p:sp>
-        <p:nvSpPr>
-          <p:cNvPr id="6" name="Shape 4"/>
-          <p:cNvSpPr/>
-          <p:nvPr/>
-        </p:nvSpPr>
-        <p:spPr>
-          <a:xfrm>
-            <a:off x="603504" y="4251960"/>
-            <a:ext cx="2788920" cy="1298448"/>
-          </a:xfrm>
-          <a:prstGeom prst="rect">
-            <a:avLst/>
-          </a:prstGeom>
-          <a:solidFill>
-            <a:srgbClr val="18231B"/>
-          </a:solidFill>
-          <a:ln w="16510">
-            <a:solidFill>
-              <a:srgbClr val="8BD8A8"/>
-            </a:solidFill>
-            <a:prstDash val="solid"/>
-          </a:ln>
-        </p:spPr>
-      </p:sp>
-      <p:sp>
-        <p:nvSpPr>
-          <p:cNvPr id="7" name="Text 5"/>
-          <p:cNvSpPr/>
-          <p:nvPr/>
-        </p:nvSpPr>
-        <p:spPr>
-          <a:xfrm>
-            <a:off x="841248" y="4434840"/>
-            <a:ext cx="2286000" cy="502920"/>
-          </a:xfrm>
-          <a:prstGeom prst="rect">
-            <a:avLst/>
-          </a:prstGeom>
-          <a:noFill/>
-          <a:ln/>
-        </p:spPr>
-        <p:txBody>
-          <a:bodyPr wrap="square" rtlCol="0" anchor="ctr">
-            <a:normAutofit/>
-          </a:bodyPr>
-          <a:lstStyle/>
-          <a:p>
-            <a:pPr indent="0" marL="0">
-              <a:buNone/>
-            </a:pPr>
-            <a:r>
-              <a:rPr lang="en-US" sz="3000" b="1" dirty="0">
-                <a:solidFill>
-                  <a:srgbClr val="F7F3E8"/>
-                </a:solidFill>
-              </a:rPr>
-              <a:t>$0.39</a:t>
-            </a:r>
-            <a:endParaRPr lang="en-US" sz="3000" dirty="0"/>
-          </a:p>
-        </p:txBody>
-      </p:sp>
-      <p:sp>
-        <p:nvSpPr>
-          <p:cNvPr id="8" name="Text 6"/>
-          <p:cNvSpPr/>
-          <p:nvPr/>
-        </p:nvSpPr>
-        <p:spPr>
-          <a:xfrm>
-            <a:off x="841248" y="4956048"/>
-            <a:ext cx="2286000" cy="320040"/>
-          </a:xfrm>
-          <a:prstGeom prst="rect">
-            <a:avLst/>
-          </a:prstGeom>
-          <a:noFill/>
-          <a:ln/>
-        </p:spPr>
-        <p:txBody>
-          <a:bodyPr wrap="square" rtlCol="0" anchor="ctr">
-            <a:normAutofit/>
-          </a:bodyPr>
-          <a:lstStyle/>
-          <a:p>
-            <a:pPr indent="0" marL="0">
-              <a:buNone/>
-            </a:pPr>
-            <a:r>
-              <a:rPr lang="en-US" sz="1050" dirty="0">
-                <a:solidFill>
-                  <a:srgbClr val="AAA79D"/>
-                </a:solidFill>
-              </a:rPr>
-              <a:t>proof spend controls $50K in capital exposure</a:t>
-            </a:r>
-            <a:endParaRPr lang="en-US" sz="1050" dirty="0"/>
-          </a:p>
-        </p:txBody>
-      </p:sp>
-      <p:sp>
-        <p:nvSpPr>
-          <p:cNvPr id="9" name="Shape 7"/>
-          <p:cNvSpPr/>
-          <p:nvPr/>
-        </p:nvSpPr>
-        <p:spPr>
-          <a:xfrm>
-            <a:off x="7022592" y="713232"/>
-            <a:ext cx="4434840" cy="5230368"/>
-          </a:xfrm>
-          <a:prstGeom prst="rect">
-            <a:avLst/>
-          </a:prstGeom>
-          <a:solidFill>
-            <a:srgbClr val="20231D"/>
-          </a:solidFill>
-          <a:ln w="12700">
-            <a:solidFill>
-              <a:srgbClr val="3A3D32"/>
-            </a:solidFill>
-            <a:prstDash val="solid"/>
-          </a:ln>
-        </p:spPr>
-      </p:sp>
-      <p:sp>
-        <p:nvSpPr>
-          <p:cNvPr id="10" name="Text 8"/>
-          <p:cNvSpPr/>
-          <p:nvPr/>
-        </p:nvSpPr>
-        <p:spPr>
-          <a:xfrm>
-            <a:off x="7370064" y="1143000"/>
-            <a:ext cx="3703320" cy="4069080"/>
-          </a:xfrm>
-          <a:prstGeom prst="rect">
-            <a:avLst/>
-          </a:prstGeom>
-          <a:noFill/>
-          <a:ln/>
-        </p:spPr>
-        <p:txBody>
-          <a:bodyPr wrap="square" rtlCol="0" anchor="ctr">
-            <a:normAutofit/>
-          </a:bodyPr>
-          <a:lstStyle/>
-          <a:p>
-            <a:pPr indent="0" marL="0">
-              <a:buNone/>
-            </a:pPr>
-            <a:r>
-              <a:rPr lang="en-US" sz="1600" b="1" dirty="0">
-                <a:solidFill>
-                  <a:srgbClr val="F7F3E8"/>
-                </a:solidFill>
-              </a:rPr>
-              <a:t>• x402-style proof gates</a:t>
-            </a:r>
-            <a:endParaRPr lang="en-US" sz="1600" dirty="0"/>
-          </a:p>
-          <a:p>
-            <a:pPr indent="0" marL="0">
-              <a:buNone/>
-            </a:pPr>
-            <a:r>
-              <a:rPr lang="en-US" sz="1600" b="1" dirty="0">
-                <a:solidFill>
-                  <a:srgbClr val="F7F3E8"/>
-                </a:solidFill>
-              </a:rPr>
-              <a:t>• Gemini extraction</a:t>
-            </a:r>
-            <a:endParaRPr lang="en-US" sz="1600" dirty="0"/>
-          </a:p>
-          <a:p>
-            <a:pPr indent="0" marL="0">
-              <a:buNone/>
-            </a:pPr>
-            <a:r>
-              <a:rPr lang="en-US" sz="1600" b="1" dirty="0">
-                <a:solidFill>
-                  <a:srgbClr val="F7F3E8"/>
-                </a:solidFill>
-              </a:rPr>
-              <a:t>• Vultr Postgres ledger</a:t>
-            </a:r>
-            <a:endParaRPr lang="en-US" sz="1600" dirty="0"/>
-          </a:p>
-        </p:txBody>
-      </p:sp>
-      <p:sp>
-        <p:nvSpPr>
-          <p:cNvPr id="11" name="Text 9"/>
-          <p:cNvSpPr/>
-          <p:nvPr/>
-        </p:nvSpPr>
-        <p:spPr>
-          <a:xfrm>
-            <a:off x="10643616" y="6236208"/>
-            <a:ext cx="685800" cy="164592"/>
-          </a:xfrm>
-          <a:prstGeom prst="rect">
-            <a:avLst/>
-          </a:prstGeom>
-          <a:noFill/>
-          <a:ln/>
-        </p:spPr>
-        <p:txBody>
-          <a:bodyPr wrap="square" rtlCol="0" anchor="ctr"/>
-          <a:lstStyle/>
-          <a:p>
-            <a:pPr algn="r" indent="0" marL="0">
-              <a:buNone/>
-            </a:pPr>
-            <a:r>
-              <a:rPr lang="en-US" sz="900" dirty="0">
-                <a:solidFill>
-                  <a:srgbClr val="C9B98B"/>
-                </a:solidFill>
-              </a:rPr>
-              <a:t>1 / 7</a:t>
-            </a:r>
-            <a:endParaRPr lang="en-US" sz="900" dirty="0"/>
-          </a:p>
-        </p:txBody>
-      </p:sp>
+      <p:pic>
+        <p:nvPicPr>
+          <p:cNvPr id="2" name="Image 0" descr="/Users/vitaliiradionov/Code/disburseguard/artifacts/submission/disburseguard-cover.png">    </p:cNvPr>
+          <p:cNvPicPr>
+            <a:picLocks noChangeAspect="1"/>
+          </p:cNvPicPr>
+          <p:nvPr/>
+        </p:nvPicPr>
+        <p:blipFill>
+          <a:blip r:embed="rId1"/>
+          <a:stretch>
+            <a:fillRect/>
+          </a:stretch>
+        </p:blipFill>
+        <p:spPr>
+          <a:xfrm>
+            <a:off x="0" y="0"/>
+            <a:ext cx="12191695" cy="6858000"/>
+          </a:xfrm>
+          <a:prstGeom prst="rect">
+            <a:avLst/>
+          </a:prstGeom>
+        </p:spPr>
+      </p:pic>
     </p:spTree>
   </p:cSld>
   <p:clrMapOvr>
@@ -1788,7 +1447,7 @@
     <p:bg>
       <p:bgPr>
         <a:solidFill>
-          <a:srgbClr val="0B0C0A"/>
+          <a:srgbClr val="F7F2E8"/>
         </a:solidFill>
       </p:bgPr>
     </p:bg>
@@ -1814,18 +1473,20 @@
         </p:nvSpPr>
         <p:spPr>
           <a:xfrm>
-            <a:off x="256032" y="256032"/>
-            <a:ext cx="11686032" cy="6355080"/>
-          </a:xfrm>
-          <a:prstGeom prst="rect">
-            <a:avLst/>
+            <a:off x="411480" y="411480"/>
+            <a:ext cx="11365992" cy="6035040"/>
+          </a:xfrm>
+          <a:prstGeom prst="rect">
+            <a:avLst>
+              <a:gd name="adj" fmla="val 2727"/>
+            </a:avLst>
           </a:prstGeom>
           <a:solidFill>
-            <a:srgbClr val="12140F"/>
+            <a:srgbClr val="FFFBF2"/>
           </a:solidFill>
           <a:ln w="12700">
             <a:solidFill>
-              <a:srgbClr val="3A3D32"/>
+              <a:srgbClr val="D8D2C4"/>
             </a:solidFill>
             <a:prstDash val="solid"/>
           </a:ln>
@@ -1839,8 +1500,8 @@
         </p:nvSpPr>
         <p:spPr>
           <a:xfrm>
-            <a:off x="566928" y="621792"/>
-            <a:ext cx="2926080" cy="237744"/>
+            <a:off x="786384" y="777240"/>
+            <a:ext cx="4206240" cy="228600"/>
           </a:xfrm>
           <a:prstGeom prst="rect">
             <a:avLst/>
@@ -1858,10 +1519,10 @@
             <a:r>
               <a:rPr lang="en-US" sz="1000" b="1" dirty="0">
                 <a:solidFill>
-                  <a:srgbClr val="C9B98B"/>
-                </a:solidFill>
-              </a:rPr>
-              <a:t>02 / WHY NOW</a:t>
+                  <a:srgbClr val="FF5C7A"/>
+                </a:solidFill>
+              </a:rPr>
+              <a:t>02 / THE GAP</a:t>
             </a:r>
             <a:endParaRPr lang="en-US" sz="1000" dirty="0"/>
           </a:p>
@@ -1875,8 +1536,8 @@
         </p:nvSpPr>
         <p:spPr>
           <a:xfrm>
-            <a:off x="566928" y="960120"/>
-            <a:ext cx="6080760" cy="1508760"/>
+            <a:off x="786384" y="1115568"/>
+            <a:ext cx="5577840" cy="1234440"/>
           </a:xfrm>
           <a:prstGeom prst="rect">
             <a:avLst/>
@@ -1894,14 +1555,14 @@
               <a:buNone/>
             </a:pPr>
             <a:r>
-              <a:rPr lang="en-US" sz="3100" b="1" dirty="0">
-                <a:solidFill>
-                  <a:srgbClr val="F7F3E8"/>
-                </a:solidFill>
-              </a:rPr>
-              <a:t>AI agents are crossing from advice into authorization.</a:t>
-            </a:r>
-            <a:endParaRPr lang="en-US" sz="3100" dirty="0"/>
+              <a:rPr lang="en-US" sz="3000" b="1" dirty="0">
+                <a:solidFill>
+                  <a:srgbClr val="111827"/>
+                </a:solidFill>
+              </a:rPr>
+              <a:t>Dashboards explain risk after money already left.</a:t>
+            </a:r>
+            <a:endParaRPr lang="en-US" sz="3000" dirty="0"/>
           </a:p>
         </p:txBody>
       </p:sp>
@@ -1913,8 +1574,8 @@
         </p:nvSpPr>
         <p:spPr>
           <a:xfrm>
-            <a:off x="594360" y="2615184"/>
-            <a:ext cx="5650992" cy="1097280"/>
+            <a:off x="804672" y="2596896"/>
+            <a:ext cx="5257800" cy="960120"/>
           </a:xfrm>
           <a:prstGeom prst="rect">
             <a:avLst/>
@@ -1932,14 +1593,14 @@
               <a:buNone/>
             </a:pPr>
             <a:r>
-              <a:rPr lang="en-US" sz="1500" dirty="0">
-                <a:solidFill>
-                  <a:srgbClr val="AAA79D"/>
-                </a:solidFill>
-              </a:rPr>
-              <a:t>Summaries are not proof. A payout agent needs a pre-payout enforcement layer, not another dashboard after the money is gone.</a:t>
-            </a:r>
-            <a:endParaRPr lang="en-US" sz="1500" dirty="0"/>
+              <a:rPr lang="en-US" sz="1400" dirty="0">
+                <a:solidFill>
+                  <a:srgbClr val="334155"/>
+                </a:solidFill>
+              </a:rPr>
+              <a:t>Autonomous finance needs enforcement before payout, not a prettier audit view after the agent has acted.</a:t>
+            </a:r>
+            <a:endParaRPr lang="en-US" sz="1400" dirty="0"/>
           </a:p>
         </p:txBody>
       </p:sp>
@@ -1951,18 +1612,20 @@
         </p:nvSpPr>
         <p:spPr>
           <a:xfrm>
-            <a:off x="603504" y="4251960"/>
-            <a:ext cx="2788920" cy="1298448"/>
-          </a:xfrm>
-          <a:prstGeom prst="rect">
-            <a:avLst/>
+            <a:off x="804672" y="4315968"/>
+            <a:ext cx="2971800" cy="1078992"/>
+          </a:xfrm>
+          <a:prstGeom prst="roundRect">
+            <a:avLst>
+              <a:gd name="adj" fmla="val 15254"/>
+            </a:avLst>
           </a:prstGeom>
           <a:solidFill>
-            <a:srgbClr val="18231B"/>
+            <a:srgbClr val="111827"/>
           </a:solidFill>
-          <a:ln w="16510">
+          <a:ln w="12700">
             <a:solidFill>
-              <a:srgbClr val="8BD8A8"/>
+              <a:srgbClr val="111827"/>
             </a:solidFill>
             <a:prstDash val="solid"/>
           </a:ln>
@@ -1976,8 +1639,8 @@
         </p:nvSpPr>
         <p:spPr>
           <a:xfrm>
-            <a:off x="841248" y="4434840"/>
-            <a:ext cx="2286000" cy="502920"/>
+            <a:off x="1051560" y="4489704"/>
+            <a:ext cx="2468880" cy="411480"/>
           </a:xfrm>
           <a:prstGeom prst="rect">
             <a:avLst/>
@@ -1995,14 +1658,14 @@
               <a:buNone/>
             </a:pPr>
             <a:r>
-              <a:rPr lang="en-US" sz="3000" b="1" dirty="0">
-                <a:solidFill>
-                  <a:srgbClr val="F7F3E8"/>
-                </a:solidFill>
-              </a:rPr>
-              <a:t>$75K</a:t>
-            </a:r>
-            <a:endParaRPr lang="en-US" sz="3000" dirty="0"/>
+              <a:rPr lang="en-US" sz="2700" b="1" dirty="0">
+                <a:solidFill>
+                  <a:srgbClr val="FFFFFF"/>
+                </a:solidFill>
+              </a:rPr>
+              <a:t>before</a:t>
+            </a:r>
+            <a:endParaRPr lang="en-US" sz="2700" dirty="0"/>
           </a:p>
         </p:txBody>
       </p:sp>
@@ -2014,8 +1677,8 @@
         </p:nvSpPr>
         <p:spPr>
           <a:xfrm>
-            <a:off x="841248" y="4956048"/>
-            <a:ext cx="2286000" cy="320040"/>
+            <a:off x="1051560" y="4928616"/>
+            <a:ext cx="2359152" cy="256032"/>
           </a:xfrm>
           <a:prstGeom prst="rect">
             <a:avLst/>
@@ -2033,14 +1696,14 @@
               <a:buNone/>
             </a:pPr>
             <a:r>
-              <a:rPr lang="en-US" sz="1050" dirty="0">
-                <a:solidFill>
-                  <a:srgbClr val="AAA79D"/>
-                </a:solidFill>
-              </a:rPr>
-              <a:t>sample payout request held before release</a:t>
-            </a:r>
-            <a:endParaRPr lang="en-US" sz="1050" dirty="0"/>
+              <a:rPr lang="en-US" sz="980" dirty="0">
+                <a:solidFill>
+                  <a:srgbClr val="DBEAFE"/>
+                </a:solidFill>
+              </a:rPr>
+              <a:t>control moves in front of the payout</a:t>
+            </a:r>
+            <a:endParaRPr lang="en-US" sz="980" dirty="0"/>
           </a:p>
         </p:txBody>
       </p:sp>
@@ -2052,18 +1715,20 @@
         </p:nvSpPr>
         <p:spPr>
           <a:xfrm>
-            <a:off x="7022592" y="713232"/>
-            <a:ext cx="4434840" cy="5230368"/>
-          </a:xfrm>
-          <a:prstGeom prst="rect">
-            <a:avLst/>
+            <a:off x="6629400" y="932688"/>
+            <a:ext cx="4389120" cy="4553712"/>
+          </a:xfrm>
+          <a:prstGeom prst="roundRect">
+            <a:avLst>
+              <a:gd name="adj" fmla="val 4167"/>
+            </a:avLst>
           </a:prstGeom>
           <a:solidFill>
-            <a:srgbClr val="20231D"/>
+            <a:srgbClr val="FFFFFF"/>
           </a:solidFill>
           <a:ln w="12700">
             <a:solidFill>
-              <a:srgbClr val="3A3D32"/>
+              <a:srgbClr val="D8D2C4"/>
             </a:solidFill>
             <a:prstDash val="solid"/>
           </a:ln>
@@ -2077,8 +1742,8 @@
         </p:nvSpPr>
         <p:spPr>
           <a:xfrm>
-            <a:off x="7370064" y="1143000"/>
-            <a:ext cx="3703320" cy="4069080"/>
+            <a:off x="7022592" y="1426464"/>
+            <a:ext cx="3657600" cy="3520440"/>
           </a:xfrm>
           <a:prstGeom prst="rect">
             <a:avLst/>
@@ -2098,10 +1763,10 @@
             <a:r>
               <a:rPr lang="en-US" sz="1600" b="1" dirty="0">
                 <a:solidFill>
-                  <a:srgbClr val="F7F3E8"/>
-                </a:solidFill>
-              </a:rPr>
-              <a:t>• Risk appears before audit</a:t>
+                  <a:srgbClr val="111827"/>
+                </a:solidFill>
+              </a:rPr>
+              <a:t>- Agent summaries are not evidence</a:t>
             </a:r>
             <a:endParaRPr lang="en-US" sz="1600" dirty="0"/>
           </a:p>
@@ -2112,10 +1777,10 @@
             <a:r>
               <a:rPr lang="en-US" sz="1600" b="1" dirty="0">
                 <a:solidFill>
-                  <a:srgbClr val="F7F3E8"/>
-                </a:solidFill>
-              </a:rPr>
-              <a:t>• Human queues do not scale</a:t>
+                  <a:srgbClr val="111827"/>
+                </a:solidFill>
+              </a:rPr>
+              <a:t>- Human queues do not scale</a:t>
             </a:r>
             <a:endParaRPr lang="en-US" sz="1600" dirty="0"/>
           </a:p>
@@ -2126,10 +1791,10 @@
             <a:r>
               <a:rPr lang="en-US" sz="1600" b="1" dirty="0">
                 <a:solidFill>
-                  <a:srgbClr val="F7F3E8"/>
-                </a:solidFill>
-              </a:rPr>
-              <a:t>• Treasury needs machine-verifiable clearance</a:t>
+                  <a:srgbClr val="111827"/>
+                </a:solidFill>
+              </a:rPr>
+              <a:t>- Treasury needs machine-verifiable proof</a:t>
             </a:r>
             <a:endParaRPr lang="en-US" sz="1600" dirty="0"/>
           </a:p>
@@ -2137,14 +1802,37 @@
       </p:sp>
       <p:sp>
         <p:nvSpPr>
-          <p:cNvPr id="11" name="Text 9"/>
-          <p:cNvSpPr/>
-          <p:nvPr/>
-        </p:nvSpPr>
-        <p:spPr>
-          <a:xfrm>
-            <a:off x="10643616" y="6236208"/>
-            <a:ext cx="685800" cy="164592"/>
+          <p:cNvPr id="11" name="Shape 9"/>
+          <p:cNvSpPr/>
+          <p:nvPr/>
+        </p:nvSpPr>
+        <p:spPr>
+          <a:xfrm>
+            <a:off x="6949440" y="5157216"/>
+            <a:ext cx="3520440" cy="0"/>
+          </a:xfrm>
+          <a:prstGeom prst="line">
+            <a:avLst/>
+          </a:prstGeom>
+          <a:noFill/>
+          <a:ln w="38100">
+            <a:solidFill>
+              <a:srgbClr val="FF5C7A"/>
+            </a:solidFill>
+            <a:prstDash val="solid"/>
+          </a:ln>
+        </p:spPr>
+      </p:sp>
+      <p:sp>
+        <p:nvSpPr>
+          <p:cNvPr id="12" name="Text 10"/>
+          <p:cNvSpPr/>
+          <p:nvPr/>
+        </p:nvSpPr>
+        <p:spPr>
+          <a:xfrm>
+            <a:off x="10378440" y="6080760"/>
+            <a:ext cx="438912" cy="164592"/>
           </a:xfrm>
           <a:prstGeom prst="rect">
             <a:avLst/>
@@ -2160,14 +1848,14 @@
               <a:buNone/>
             </a:pPr>
             <a:r>
-              <a:rPr lang="en-US" sz="900" dirty="0">
-                <a:solidFill>
-                  <a:srgbClr val="C9B98B"/>
+              <a:rPr lang="en-US" sz="800" dirty="0">
+                <a:solidFill>
+                  <a:srgbClr val="64748B"/>
                 </a:solidFill>
               </a:rPr>
               <a:t>2 / 7</a:t>
             </a:r>
-            <a:endParaRPr lang="en-US" sz="900" dirty="0"/>
+            <a:endParaRPr lang="en-US" sz="800" dirty="0"/>
           </a:p>
         </p:txBody>
       </p:sp>
@@ -2185,7 +1873,7 @@
     <p:bg>
       <p:bgPr>
         <a:solidFill>
-          <a:srgbClr val="0B0C0A"/>
+          <a:srgbClr val="F7F2E8"/>
         </a:solidFill>
       </p:bgPr>
     </p:bg>
@@ -2211,18 +1899,20 @@
         </p:nvSpPr>
         <p:spPr>
           <a:xfrm>
-            <a:off x="256032" y="256032"/>
-            <a:ext cx="11686032" cy="6355080"/>
-          </a:xfrm>
-          <a:prstGeom prst="rect">
-            <a:avLst/>
+            <a:off x="411480" y="411480"/>
+            <a:ext cx="11365992" cy="6035040"/>
+          </a:xfrm>
+          <a:prstGeom prst="rect">
+            <a:avLst>
+              <a:gd name="adj" fmla="val 2727"/>
+            </a:avLst>
           </a:prstGeom>
           <a:solidFill>
-            <a:srgbClr val="12140F"/>
+            <a:srgbClr val="FFFBF2"/>
           </a:solidFill>
           <a:ln w="12700">
             <a:solidFill>
-              <a:srgbClr val="3A3D32"/>
+              <a:srgbClr val="D8D2C4"/>
             </a:solidFill>
             <a:prstDash val="solid"/>
           </a:ln>
@@ -2236,8 +1926,8 @@
         </p:nvSpPr>
         <p:spPr>
           <a:xfrm>
-            <a:off x="566928" y="621792"/>
-            <a:ext cx="2926080" cy="237744"/>
+            <a:off x="786384" y="777240"/>
+            <a:ext cx="4206240" cy="228600"/>
           </a:xfrm>
           <a:prstGeom prst="rect">
             <a:avLst/>
@@ -2255,7 +1945,7 @@
             <a:r>
               <a:rPr lang="en-US" sz="1000" b="1" dirty="0">
                 <a:solidFill>
-                  <a:srgbClr val="C9B98B"/>
+                  <a:srgbClr val="FFB020"/>
                 </a:solidFill>
               </a:rPr>
               <a:t>03 / PAID PROOF</a:t>
@@ -2272,8 +1962,8 @@
         </p:nvSpPr>
         <p:spPr>
           <a:xfrm>
-            <a:off x="566928" y="960120"/>
-            <a:ext cx="6080760" cy="1508760"/>
+            <a:off x="786384" y="1115568"/>
+            <a:ext cx="5577840" cy="1234440"/>
           </a:xfrm>
           <a:prstGeom prst="rect">
             <a:avLst/>
@@ -2291,14 +1981,14 @@
               <a:buNone/>
             </a:pPr>
             <a:r>
-              <a:rPr lang="en-US" sz="3100" b="1" dirty="0">
-                <a:solidFill>
-                  <a:srgbClr val="F7F3E8"/>
-                </a:solidFill>
-              </a:rPr>
-              <a:t>Evidence is protected by payment, not trust.</a:t>
-            </a:r>
-            <a:endParaRPr lang="en-US" sz="3100" dirty="0"/>
+              <a:rPr lang="en-US" sz="3000" b="1" dirty="0">
+                <a:solidFill>
+                  <a:srgbClr val="111827"/>
+                </a:solidFill>
+              </a:rPr>
+              <a:t>Evidence is a paid gate, not a trusted checkbox.</a:t>
+            </a:r>
+            <a:endParaRPr lang="en-US" sz="3000" dirty="0"/>
           </a:p>
         </p:txBody>
       </p:sp>
@@ -2310,8 +2000,8 @@
         </p:nvSpPr>
         <p:spPr>
           <a:xfrm>
-            <a:off x="594360" y="2615184"/>
-            <a:ext cx="5650992" cy="1097280"/>
+            <a:off x="804672" y="2596896"/>
+            <a:ext cx="5257800" cy="960120"/>
           </a:xfrm>
           <a:prstGeom prst="rect">
             <a:avLst/>
@@ -2329,14 +2019,14 @@
               <a:buNone/>
             </a:pPr>
             <a:r>
-              <a:rPr lang="en-US" sz="1500" dirty="0">
-                <a:solidFill>
-                  <a:srgbClr val="AAA79D"/>
-                </a:solidFill>
-              </a:rPr>
-              <a:t>Proof endpoints return HTTP 402 until the agent pays. Only paid receipts can enter the treasury policy decision.</a:t>
-            </a:r>
-            <a:endParaRPr lang="en-US" sz="1500" dirty="0"/>
+              <a:rPr lang="en-US" sz="1400" dirty="0">
+                <a:solidFill>
+                  <a:srgbClr val="334155"/>
+                </a:solidFill>
+              </a:rPr>
+              <a:t>Protected proof endpoints deny access with HTTP 402. The Payment Agent must create receipts before evidence can influence the treasury decision.</a:t>
+            </a:r>
+            <a:endParaRPr lang="en-US" sz="1400" dirty="0"/>
           </a:p>
         </p:txBody>
       </p:sp>
@@ -2348,18 +2038,20 @@
         </p:nvSpPr>
         <p:spPr>
           <a:xfrm>
-            <a:off x="603504" y="4251960"/>
-            <a:ext cx="2788920" cy="1298448"/>
-          </a:xfrm>
-          <a:prstGeom prst="rect">
-            <a:avLst/>
+            <a:off x="804672" y="4315968"/>
+            <a:ext cx="2971800" cy="1078992"/>
+          </a:xfrm>
+          <a:prstGeom prst="roundRect">
+            <a:avLst>
+              <a:gd name="adj" fmla="val 15254"/>
+            </a:avLst>
           </a:prstGeom>
           <a:solidFill>
-            <a:srgbClr val="1D1618"/>
+            <a:srgbClr val="111827"/>
           </a:solidFill>
-          <a:ln w="16510">
+          <a:ln w="12700">
             <a:solidFill>
-              <a:srgbClr val="F08BA0"/>
+              <a:srgbClr val="111827"/>
             </a:solidFill>
             <a:prstDash val="solid"/>
           </a:ln>
@@ -2373,8 +2065,8 @@
         </p:nvSpPr>
         <p:spPr>
           <a:xfrm>
-            <a:off x="841248" y="4434840"/>
-            <a:ext cx="2286000" cy="502920"/>
+            <a:off x="1051560" y="4489704"/>
+            <a:ext cx="2468880" cy="411480"/>
           </a:xfrm>
           <a:prstGeom prst="rect">
             <a:avLst/>
@@ -2392,14 +2084,14 @@
               <a:buNone/>
             </a:pPr>
             <a:r>
-              <a:rPr lang="en-US" sz="3000" b="1" dirty="0">
-                <a:solidFill>
-                  <a:srgbClr val="F7F3E8"/>
+              <a:rPr lang="en-US" sz="2700" b="1" dirty="0">
+                <a:solidFill>
+                  <a:srgbClr val="FFFFFF"/>
                 </a:solidFill>
               </a:rPr>
               <a:t>402</a:t>
             </a:r>
-            <a:endParaRPr lang="en-US" sz="3000" dirty="0"/>
+            <a:endParaRPr lang="en-US" sz="2700" dirty="0"/>
           </a:p>
         </p:txBody>
       </p:sp>
@@ -2411,8 +2103,8 @@
         </p:nvSpPr>
         <p:spPr>
           <a:xfrm>
-            <a:off x="841248" y="4956048"/>
-            <a:ext cx="2286000" cy="320040"/>
+            <a:off x="1051560" y="4928616"/>
+            <a:ext cx="2359152" cy="256032"/>
           </a:xfrm>
           <a:prstGeom prst="rect">
             <a:avLst/>
@@ -2430,14 +2122,14 @@
               <a:buNone/>
             </a:pPr>
             <a:r>
-              <a:rPr lang="en-US" sz="1050" dirty="0">
-                <a:solidFill>
-                  <a:srgbClr val="AAA79D"/>
+              <a:rPr lang="en-US" sz="980" dirty="0">
+                <a:solidFill>
+                  <a:srgbClr val="DBEAFE"/>
                 </a:solidFill>
               </a:rPr>
               <a:t>payment required before proof access</a:t>
             </a:r>
-            <a:endParaRPr lang="en-US" sz="1050" dirty="0"/>
+            <a:endParaRPr lang="en-US" sz="980" dirty="0"/>
           </a:p>
         </p:txBody>
       </p:sp>
@@ -2449,18 +2141,20 @@
         </p:nvSpPr>
         <p:spPr>
           <a:xfrm>
-            <a:off x="7022592" y="713232"/>
-            <a:ext cx="4434840" cy="5230368"/>
-          </a:xfrm>
-          <a:prstGeom prst="rect">
-            <a:avLst/>
+            <a:off x="6629400" y="932688"/>
+            <a:ext cx="4389120" cy="4553712"/>
+          </a:xfrm>
+          <a:prstGeom prst="roundRect">
+            <a:avLst>
+              <a:gd name="adj" fmla="val 4167"/>
+            </a:avLst>
           </a:prstGeom>
           <a:solidFill>
-            <a:srgbClr val="20231D"/>
+            <a:srgbClr val="FFFFFF"/>
           </a:solidFill>
           <a:ln w="12700">
             <a:solidFill>
-              <a:srgbClr val="3A3D32"/>
+              <a:srgbClr val="D8D2C4"/>
             </a:solidFill>
             <a:prstDash val="solid"/>
           </a:ln>
@@ -2474,8 +2168,8 @@
         </p:nvSpPr>
         <p:spPr>
           <a:xfrm>
-            <a:off x="7370064" y="1143000"/>
-            <a:ext cx="3703320" cy="4069080"/>
+            <a:off x="7022592" y="1426464"/>
+            <a:ext cx="3657600" cy="3520440"/>
           </a:xfrm>
           <a:prstGeom prst="rect">
             <a:avLst/>
@@ -2495,10 +2189,10 @@
             <a:r>
               <a:rPr lang="en-US" sz="1600" b="1" dirty="0">
                 <a:solidFill>
-                  <a:srgbClr val="F7F3E8"/>
-                </a:solidFill>
-              </a:rPr>
-              <a:t>• vendor-risk</a:t>
+                  <a:srgbClr val="111827"/>
+                </a:solidFill>
+              </a:rPr>
+              <a:t>- vendor-risk</a:t>
             </a:r>
             <a:endParaRPr lang="en-US" sz="1600" dirty="0"/>
           </a:p>
@@ -2509,10 +2203,10 @@
             <a:r>
               <a:rPr lang="en-US" sz="1600" b="1" dirty="0">
                 <a:solidFill>
-                  <a:srgbClr val="F7F3E8"/>
-                </a:solidFill>
-              </a:rPr>
-              <a:t>• recipient-match</a:t>
+                  <a:srgbClr val="111827"/>
+                </a:solidFill>
+              </a:rPr>
+              <a:t>- recipient-match</a:t>
             </a:r>
             <a:endParaRPr lang="en-US" sz="1600" dirty="0"/>
           </a:p>
@@ -2523,10 +2217,10 @@
             <a:r>
               <a:rPr lang="en-US" sz="1600" b="1" dirty="0">
                 <a:solidFill>
-                  <a:srgbClr val="F7F3E8"/>
-                </a:solidFill>
-              </a:rPr>
-              <a:t>• sanctions-screen</a:t>
+                  <a:srgbClr val="111827"/>
+                </a:solidFill>
+              </a:rPr>
+              <a:t>- sanctions-screen</a:t>
             </a:r>
             <a:endParaRPr lang="en-US" sz="1600" dirty="0"/>
           </a:p>
@@ -2537,10 +2231,10 @@
             <a:r>
               <a:rPr lang="en-US" sz="1600" b="1" dirty="0">
                 <a:solidFill>
-                  <a:srgbClr val="F7F3E8"/>
-                </a:solidFill>
-              </a:rPr>
-              <a:t>• delivery-attestation</a:t>
+                  <a:srgbClr val="111827"/>
+                </a:solidFill>
+              </a:rPr>
+              <a:t>- delivery-attestation</a:t>
             </a:r>
             <a:endParaRPr lang="en-US" sz="1600" dirty="0"/>
           </a:p>
@@ -2548,14 +2242,37 @@
       </p:sp>
       <p:sp>
         <p:nvSpPr>
-          <p:cNvPr id="11" name="Text 9"/>
-          <p:cNvSpPr/>
-          <p:nvPr/>
-        </p:nvSpPr>
-        <p:spPr>
-          <a:xfrm>
-            <a:off x="10643616" y="6236208"/>
-            <a:ext cx="685800" cy="164592"/>
+          <p:cNvPr id="11" name="Shape 9"/>
+          <p:cNvSpPr/>
+          <p:nvPr/>
+        </p:nvSpPr>
+        <p:spPr>
+          <a:xfrm>
+            <a:off x="6949440" y="5157216"/>
+            <a:ext cx="3520440" cy="0"/>
+          </a:xfrm>
+          <a:prstGeom prst="line">
+            <a:avLst/>
+          </a:prstGeom>
+          <a:noFill/>
+          <a:ln w="38100">
+            <a:solidFill>
+              <a:srgbClr val="FFB020"/>
+            </a:solidFill>
+            <a:prstDash val="solid"/>
+          </a:ln>
+        </p:spPr>
+      </p:sp>
+      <p:sp>
+        <p:nvSpPr>
+          <p:cNvPr id="12" name="Text 10"/>
+          <p:cNvSpPr/>
+          <p:nvPr/>
+        </p:nvSpPr>
+        <p:spPr>
+          <a:xfrm>
+            <a:off x="10378440" y="6080760"/>
+            <a:ext cx="438912" cy="164592"/>
           </a:xfrm>
           <a:prstGeom prst="rect">
             <a:avLst/>
@@ -2571,14 +2288,14 @@
               <a:buNone/>
             </a:pPr>
             <a:r>
-              <a:rPr lang="en-US" sz="900" dirty="0">
-                <a:solidFill>
-                  <a:srgbClr val="C9B98B"/>
+              <a:rPr lang="en-US" sz="800" dirty="0">
+                <a:solidFill>
+                  <a:srgbClr val="64748B"/>
                 </a:solidFill>
               </a:rPr>
               <a:t>3 / 7</a:t>
             </a:r>
-            <a:endParaRPr lang="en-US" sz="900" dirty="0"/>
+            <a:endParaRPr lang="en-US" sz="800" dirty="0"/>
           </a:p>
         </p:txBody>
       </p:sp>
@@ -2596,7 +2313,7 @@
     <p:bg>
       <p:bgPr>
         <a:solidFill>
-          <a:srgbClr val="0B0C0A"/>
+          <a:srgbClr val="F7F2E8"/>
         </a:solidFill>
       </p:bgPr>
     </p:bg>
@@ -2622,18 +2339,20 @@
         </p:nvSpPr>
         <p:spPr>
           <a:xfrm>
-            <a:off x="256032" y="256032"/>
-            <a:ext cx="11686032" cy="6355080"/>
-          </a:xfrm>
-          <a:prstGeom prst="rect">
-            <a:avLst/>
+            <a:off x="411480" y="411480"/>
+            <a:ext cx="11365992" cy="6035040"/>
+          </a:xfrm>
+          <a:prstGeom prst="rect">
+            <a:avLst>
+              <a:gd name="adj" fmla="val 2727"/>
+            </a:avLst>
           </a:prstGeom>
           <a:solidFill>
-            <a:srgbClr val="12140F"/>
+            <a:srgbClr val="FFFBF2"/>
           </a:solidFill>
           <a:ln w="12700">
             <a:solidFill>
-              <a:srgbClr val="3A3D32"/>
+              <a:srgbClr val="D8D2C4"/>
             </a:solidFill>
             <a:prstDash val="solid"/>
           </a:ln>
@@ -2647,8 +2366,8 @@
         </p:nvSpPr>
         <p:spPr>
           <a:xfrm>
-            <a:off x="566928" y="621792"/>
-            <a:ext cx="2926080" cy="237744"/>
+            <a:off x="786384" y="777240"/>
+            <a:ext cx="4206240" cy="228600"/>
           </a:xfrm>
           <a:prstGeom prst="rect">
             <a:avLst/>
@@ -2666,10 +2385,10 @@
             <a:r>
               <a:rPr lang="en-US" sz="1000" b="1" dirty="0">
                 <a:solidFill>
-                  <a:srgbClr val="C9B98B"/>
-                </a:solidFill>
-              </a:rPr>
-              <a:t>04 / AGENT WORKFLOW</a:t>
+                  <a:srgbClr val="6D4AFF"/>
+                </a:solidFill>
+              </a:rPr>
+              <a:t>04 / AGENT LOOP</a:t>
             </a:r>
             <a:endParaRPr lang="en-US" sz="1000" dirty="0"/>
           </a:p>
@@ -2683,8 +2402,8 @@
         </p:nvSpPr>
         <p:spPr>
           <a:xfrm>
-            <a:off x="566928" y="960120"/>
-            <a:ext cx="6080760" cy="1508760"/>
+            <a:off x="786384" y="1115568"/>
+            <a:ext cx="5577840" cy="1234440"/>
           </a:xfrm>
           <a:prstGeom prst="rect">
             <a:avLst/>
@@ -2702,14 +2421,14 @@
               <a:buNone/>
             </a:pPr>
             <a:r>
-              <a:rPr lang="en-US" sz="3100" b="1" dirty="0">
-                <a:solidFill>
-                  <a:srgbClr val="F7F3E8"/>
-                </a:solidFill>
-              </a:rPr>
-              <a:t>The product is an acting agent, not a passive dashboard.</a:t>
-            </a:r>
-            <a:endParaRPr lang="en-US" sz="3100" dirty="0"/>
+              <a:rPr lang="en-US" sz="3000" b="1" dirty="0">
+                <a:solidFill>
+                  <a:srgbClr val="111827"/>
+                </a:solidFill>
+              </a:rPr>
+              <a:t>The demo acts through a full clearance chain.</a:t>
+            </a:r>
+            <a:endParaRPr lang="en-US" sz="3000" dirty="0"/>
           </a:p>
         </p:txBody>
       </p:sp>
@@ -2721,8 +2440,8 @@
         </p:nvSpPr>
         <p:spPr>
           <a:xfrm>
-            <a:off x="594360" y="2615184"/>
-            <a:ext cx="5650992" cy="1097280"/>
+            <a:off x="804672" y="2596896"/>
+            <a:ext cx="5257800" cy="960120"/>
           </a:xfrm>
           <a:prstGeom prst="rect">
             <a:avLst/>
@@ -2740,14 +2459,14 @@
               <a:buNone/>
             </a:pPr>
             <a:r>
-              <a:rPr lang="en-US" sz="1500" dirty="0">
-                <a:solidFill>
-                  <a:srgbClr val="AAA79D"/>
-                </a:solidFill>
-              </a:rPr>
-              <a:t>Intake Agent extracts context, Proof Agent creates the plan, Payment Agent buys receipts, Policy Guard decides, and Audit Agent signs the packet.</a:t>
-            </a:r>
-            <a:endParaRPr lang="en-US" sz="1500" dirty="0"/>
+              <a:rPr lang="en-US" sz="1400" dirty="0">
+                <a:solidFill>
+                  <a:srgbClr val="334155"/>
+                </a:solidFill>
+              </a:rPr>
+              <a:t>Intake Agent, Proof Agent, Payment Agent, Policy Guard, and Audit Agent complete one verifiable payout loop instead of only displaying status.</a:t>
+            </a:r>
+            <a:endParaRPr lang="en-US" sz="1400" dirty="0"/>
           </a:p>
         </p:txBody>
       </p:sp>
@@ -2759,18 +2478,20 @@
         </p:nvSpPr>
         <p:spPr>
           <a:xfrm>
-            <a:off x="603504" y="4251960"/>
-            <a:ext cx="2788920" cy="1298448"/>
-          </a:xfrm>
-          <a:prstGeom prst="rect">
-            <a:avLst/>
+            <a:off x="804672" y="4315968"/>
+            <a:ext cx="2971800" cy="1078992"/>
+          </a:xfrm>
+          <a:prstGeom prst="roundRect">
+            <a:avLst>
+              <a:gd name="adj" fmla="val 15254"/>
+            </a:avLst>
           </a:prstGeom>
           <a:solidFill>
-            <a:srgbClr val="18231B"/>
+            <a:srgbClr val="111827"/>
           </a:solidFill>
-          <a:ln w="16510">
+          <a:ln w="12700">
             <a:solidFill>
-              <a:srgbClr val="8BD8A8"/>
+              <a:srgbClr val="111827"/>
             </a:solidFill>
             <a:prstDash val="solid"/>
           </a:ln>
@@ -2784,8 +2505,8 @@
         </p:nvSpPr>
         <p:spPr>
           <a:xfrm>
-            <a:off x="841248" y="4434840"/>
-            <a:ext cx="2286000" cy="502920"/>
+            <a:off x="1051560" y="4489704"/>
+            <a:ext cx="2468880" cy="411480"/>
           </a:xfrm>
           <a:prstGeom prst="rect">
             <a:avLst/>
@@ -2803,14 +2524,14 @@
               <a:buNone/>
             </a:pPr>
             <a:r>
-              <a:rPr lang="en-US" sz="3000" b="1" dirty="0">
-                <a:solidFill>
-                  <a:srgbClr val="F7F3E8"/>
+              <a:rPr lang="en-US" sz="2700" b="1" dirty="0">
+                <a:solidFill>
+                  <a:srgbClr val="FFFFFF"/>
                 </a:solidFill>
               </a:rPr>
               <a:t>5</a:t>
             </a:r>
-            <a:endParaRPr lang="en-US" sz="3000" dirty="0"/>
+            <a:endParaRPr lang="en-US" sz="2700" dirty="0"/>
           </a:p>
         </p:txBody>
       </p:sp>
@@ -2822,8 +2543,8 @@
         </p:nvSpPr>
         <p:spPr>
           <a:xfrm>
-            <a:off x="841248" y="4956048"/>
-            <a:ext cx="2286000" cy="320040"/>
+            <a:off x="1051560" y="4928616"/>
+            <a:ext cx="2359152" cy="256032"/>
           </a:xfrm>
           <a:prstGeom prst="rect">
             <a:avLst/>
@@ -2841,14 +2562,14 @@
               <a:buNone/>
             </a:pPr>
             <a:r>
-              <a:rPr lang="en-US" sz="1050" dirty="0">
-                <a:solidFill>
-                  <a:srgbClr val="AAA79D"/>
-                </a:solidFill>
-              </a:rPr>
-              <a:t>agents in one clearance loop</a:t>
-            </a:r>
-            <a:endParaRPr lang="en-US" sz="1050" dirty="0"/>
+              <a:rPr lang="en-US" sz="980" dirty="0">
+                <a:solidFill>
+                  <a:srgbClr val="DBEAFE"/>
+                </a:solidFill>
+              </a:rPr>
+              <a:t>agents in the clearance loop</a:t>
+            </a:r>
+            <a:endParaRPr lang="en-US" sz="980" dirty="0"/>
           </a:p>
         </p:txBody>
       </p:sp>
@@ -2860,18 +2581,20 @@
         </p:nvSpPr>
         <p:spPr>
           <a:xfrm>
-            <a:off x="7022592" y="713232"/>
-            <a:ext cx="4434840" cy="5230368"/>
-          </a:xfrm>
-          <a:prstGeom prst="rect">
-            <a:avLst/>
+            <a:off x="6629400" y="932688"/>
+            <a:ext cx="4389120" cy="4553712"/>
+          </a:xfrm>
+          <a:prstGeom prst="roundRect">
+            <a:avLst>
+              <a:gd name="adj" fmla="val 4167"/>
+            </a:avLst>
           </a:prstGeom>
           <a:solidFill>
-            <a:srgbClr val="20231D"/>
+            <a:srgbClr val="FFFFFF"/>
           </a:solidFill>
           <a:ln w="12700">
             <a:solidFill>
-              <a:srgbClr val="3A3D32"/>
+              <a:srgbClr val="D8D2C4"/>
             </a:solidFill>
             <a:prstDash val="solid"/>
           </a:ln>
@@ -2885,8 +2608,8 @@
         </p:nvSpPr>
         <p:spPr>
           <a:xfrm>
-            <a:off x="7370064" y="1143000"/>
-            <a:ext cx="3703320" cy="4069080"/>
+            <a:off x="7022592" y="1426464"/>
+            <a:ext cx="3657600" cy="3520440"/>
           </a:xfrm>
           <a:prstGeom prst="rect">
             <a:avLst/>
@@ -2906,10 +2629,10 @@
             <a:r>
               <a:rPr lang="en-US" sz="1600" b="1" dirty="0">
                 <a:solidFill>
-                  <a:srgbClr val="F7F3E8"/>
-                </a:solidFill>
-              </a:rPr>
-              <a:t>• Payout intent</a:t>
+                  <a:srgbClr val="111827"/>
+                </a:solidFill>
+              </a:rPr>
+              <a:t>- Extract</a:t>
             </a:r>
             <a:endParaRPr lang="en-US" sz="1600" dirty="0"/>
           </a:p>
@@ -2920,10 +2643,10 @@
             <a:r>
               <a:rPr lang="en-US" sz="1600" b="1" dirty="0">
                 <a:solidFill>
-                  <a:srgbClr val="F7F3E8"/>
-                </a:solidFill>
-              </a:rPr>
-              <a:t>• Proof plan</a:t>
+                  <a:srgbClr val="111827"/>
+                </a:solidFill>
+              </a:rPr>
+              <a:t>- Plan</a:t>
             </a:r>
             <a:endParaRPr lang="en-US" sz="1600" dirty="0"/>
           </a:p>
@@ -2934,10 +2657,10 @@
             <a:r>
               <a:rPr lang="en-US" sz="1600" b="1" dirty="0">
                 <a:solidFill>
-                  <a:srgbClr val="F7F3E8"/>
-                </a:solidFill>
-              </a:rPr>
-              <a:t>• Paid receipts</a:t>
+                  <a:srgbClr val="111827"/>
+                </a:solidFill>
+              </a:rPr>
+              <a:t>- Pay</a:t>
             </a:r>
             <a:endParaRPr lang="en-US" sz="1600" dirty="0"/>
           </a:p>
@@ -2948,10 +2671,10 @@
             <a:r>
               <a:rPr lang="en-US" sz="1600" b="1" dirty="0">
                 <a:solidFill>
-                  <a:srgbClr val="F7F3E8"/>
-                </a:solidFill>
-              </a:rPr>
-              <a:t>• Policy outcome</a:t>
+                  <a:srgbClr val="111827"/>
+                </a:solidFill>
+              </a:rPr>
+              <a:t>- Decide</a:t>
             </a:r>
             <a:endParaRPr lang="en-US" sz="1600" dirty="0"/>
           </a:p>
@@ -2962,10 +2685,10 @@
             <a:r>
               <a:rPr lang="en-US" sz="1600" b="1" dirty="0">
                 <a:solidFill>
-                  <a:srgbClr val="F7F3E8"/>
-                </a:solidFill>
-              </a:rPr>
-              <a:t>• Signed packet</a:t>
+                  <a:srgbClr val="111827"/>
+                </a:solidFill>
+              </a:rPr>
+              <a:t>- Sign and ledger</a:t>
             </a:r>
             <a:endParaRPr lang="en-US" sz="1600" dirty="0"/>
           </a:p>
@@ -2973,14 +2696,37 @@
       </p:sp>
       <p:sp>
         <p:nvSpPr>
-          <p:cNvPr id="11" name="Text 9"/>
-          <p:cNvSpPr/>
-          <p:nvPr/>
-        </p:nvSpPr>
-        <p:spPr>
-          <a:xfrm>
-            <a:off x="10643616" y="6236208"/>
-            <a:ext cx="685800" cy="164592"/>
+          <p:cNvPr id="11" name="Shape 9"/>
+          <p:cNvSpPr/>
+          <p:nvPr/>
+        </p:nvSpPr>
+        <p:spPr>
+          <a:xfrm>
+            <a:off x="6949440" y="5157216"/>
+            <a:ext cx="3520440" cy="0"/>
+          </a:xfrm>
+          <a:prstGeom prst="line">
+            <a:avLst/>
+          </a:prstGeom>
+          <a:noFill/>
+          <a:ln w="38100">
+            <a:solidFill>
+              <a:srgbClr val="6D4AFF"/>
+            </a:solidFill>
+            <a:prstDash val="solid"/>
+          </a:ln>
+        </p:spPr>
+      </p:sp>
+      <p:sp>
+        <p:nvSpPr>
+          <p:cNvPr id="12" name="Text 10"/>
+          <p:cNvSpPr/>
+          <p:nvPr/>
+        </p:nvSpPr>
+        <p:spPr>
+          <a:xfrm>
+            <a:off x="10378440" y="6080760"/>
+            <a:ext cx="438912" cy="164592"/>
           </a:xfrm>
           <a:prstGeom prst="rect">
             <a:avLst/>
@@ -2996,14 +2742,14 @@
               <a:buNone/>
             </a:pPr>
             <a:r>
-              <a:rPr lang="en-US" sz="900" dirty="0">
-                <a:solidFill>
-                  <a:srgbClr val="C9B98B"/>
+              <a:rPr lang="en-US" sz="800" dirty="0">
+                <a:solidFill>
+                  <a:srgbClr val="64748B"/>
                 </a:solidFill>
               </a:rPr>
               <a:t>4 / 7</a:t>
             </a:r>
-            <a:endParaRPr lang="en-US" sz="900" dirty="0"/>
+            <a:endParaRPr lang="en-US" sz="800" dirty="0"/>
           </a:p>
         </p:txBody>
       </p:sp>
@@ -3021,7 +2767,7 @@
     <p:bg>
       <p:bgPr>
         <a:solidFill>
-          <a:srgbClr val="0B0C0A"/>
+          <a:srgbClr val="F7F2E8"/>
         </a:solidFill>
       </p:bgPr>
     </p:bg>
@@ -3047,18 +2793,20 @@
         </p:nvSpPr>
         <p:spPr>
           <a:xfrm>
-            <a:off x="256032" y="256032"/>
-            <a:ext cx="11686032" cy="6355080"/>
-          </a:xfrm>
-          <a:prstGeom prst="rect">
-            <a:avLst/>
+            <a:off x="411480" y="411480"/>
+            <a:ext cx="11365992" cy="6035040"/>
+          </a:xfrm>
+          <a:prstGeom prst="rect">
+            <a:avLst>
+              <a:gd name="adj" fmla="val 2727"/>
+            </a:avLst>
           </a:prstGeom>
           <a:solidFill>
-            <a:srgbClr val="12140F"/>
+            <a:srgbClr val="FFFBF2"/>
           </a:solidFill>
           <a:ln w="12700">
             <a:solidFill>
-              <a:srgbClr val="3A3D32"/>
+              <a:srgbClr val="D8D2C4"/>
             </a:solidFill>
             <a:prstDash val="solid"/>
           </a:ln>
@@ -3072,8 +2820,8 @@
         </p:nvSpPr>
         <p:spPr>
           <a:xfrm>
-            <a:off x="566928" y="621792"/>
-            <a:ext cx="2926080" cy="237744"/>
+            <a:off x="786384" y="777240"/>
+            <a:ext cx="4206240" cy="228600"/>
           </a:xfrm>
           <a:prstGeom prst="rect">
             <a:avLst/>
@@ -3091,10 +2839,10 @@
             <a:r>
               <a:rPr lang="en-US" sz="1000" b="1" dirty="0">
                 <a:solidFill>
-                  <a:srgbClr val="C9B98B"/>
-                </a:solidFill>
-              </a:rPr>
-              <a:t>05 / TREASURY DECISION</a:t>
+                  <a:srgbClr val="36C78A"/>
+                </a:solidFill>
+              </a:rPr>
+              <a:t>05 / LIVE RESULT</a:t>
             </a:r>
             <a:endParaRPr lang="en-US" sz="1000" dirty="0"/>
           </a:p>
@@ -3108,8 +2856,8 @@
         </p:nvSpPr>
         <p:spPr>
           <a:xfrm>
-            <a:off x="566928" y="960120"/>
-            <a:ext cx="6080760" cy="1508760"/>
+            <a:off x="786384" y="1115568"/>
+            <a:ext cx="5577840" cy="1234440"/>
           </a:xfrm>
           <a:prstGeom prst="rect">
             <a:avLst/>
@@ -3127,14 +2875,14 @@
               <a:buNone/>
             </a:pPr>
             <a:r>
-              <a:rPr lang="en-US" sz="3100" b="1" dirty="0">
-                <a:solidFill>
-                  <a:srgbClr val="F7F3E8"/>
-                </a:solidFill>
-              </a:rPr>
-              <a:t>Proof quality directly controls how much capital can move.</a:t>
-            </a:r>
-            <a:endParaRPr lang="en-US" sz="3100" dirty="0"/>
+              <a:rPr lang="en-US" sz="3000" b="1" dirty="0">
+                <a:solidFill>
+                  <a:srgbClr val="111827"/>
+                </a:solidFill>
+              </a:rPr>
+              <a:t>$0.39 of proof spend controls $50K of exposure.</a:t>
+            </a:r>
+            <a:endParaRPr lang="en-US" sz="3000" dirty="0"/>
           </a:p>
         </p:txBody>
       </p:sp>
@@ -3146,8 +2894,8 @@
         </p:nvSpPr>
         <p:spPr>
           <a:xfrm>
-            <a:off x="594360" y="2615184"/>
-            <a:ext cx="5650992" cy="1097280"/>
+            <a:off x="804672" y="2596896"/>
+            <a:ext cx="5257800" cy="960120"/>
           </a:xfrm>
           <a:prstGeom prst="rect">
             <a:avLst/>
@@ -3165,14 +2913,14 @@
               <a:buNone/>
             </a:pPr>
             <a:r>
-              <a:rPr lang="en-US" sz="1500" dirty="0">
-                <a:solidFill>
-                  <a:srgbClr val="AAA79D"/>
-                </a:solidFill>
-              </a:rPr>
-              <a:t>In the live scenario, DisburseGuard limits a $75,000 payout to $25,000 and keeps $50,000 controlled until better proof arrives.</a:t>
-            </a:r>
-            <a:endParaRPr lang="en-US" sz="1500" dirty="0"/>
+              <a:rPr lang="en-US" sz="1400" dirty="0">
+                <a:solidFill>
+                  <a:srgbClr val="334155"/>
+                </a:solidFill>
+              </a:rPr>
+              <a:t>In the high-value reserve scenario, DisburseGuard limits a $75,000 request to $25,000 and keeps the remaining $50,000 blocked until stronger proof arrives.</a:t>
+            </a:r>
+            <a:endParaRPr lang="en-US" sz="1400" dirty="0"/>
           </a:p>
         </p:txBody>
       </p:sp>
@@ -3184,18 +2932,20 @@
         </p:nvSpPr>
         <p:spPr>
           <a:xfrm>
-            <a:off x="603504" y="4251960"/>
-            <a:ext cx="2788920" cy="1298448"/>
-          </a:xfrm>
-          <a:prstGeom prst="rect">
-            <a:avLst/>
+            <a:off x="804672" y="4315968"/>
+            <a:ext cx="2971800" cy="1078992"/>
+          </a:xfrm>
+          <a:prstGeom prst="roundRect">
+            <a:avLst>
+              <a:gd name="adj" fmla="val 15254"/>
+            </a:avLst>
           </a:prstGeom>
           <a:solidFill>
-            <a:srgbClr val="18231B"/>
+            <a:srgbClr val="111827"/>
           </a:solidFill>
-          <a:ln w="16510">
+          <a:ln w="12700">
             <a:solidFill>
-              <a:srgbClr val="8BD8A8"/>
+              <a:srgbClr val="111827"/>
             </a:solidFill>
             <a:prstDash val="solid"/>
           </a:ln>
@@ -3209,8 +2959,8 @@
         </p:nvSpPr>
         <p:spPr>
           <a:xfrm>
-            <a:off x="841248" y="4434840"/>
-            <a:ext cx="2286000" cy="502920"/>
+            <a:off x="1051560" y="4489704"/>
+            <a:ext cx="2468880" cy="411480"/>
           </a:xfrm>
           <a:prstGeom prst="rect">
             <a:avLst/>
@@ -3228,14 +2978,14 @@
               <a:buNone/>
             </a:pPr>
             <a:r>
-              <a:rPr lang="en-US" sz="3000" b="1" dirty="0">
-                <a:solidFill>
-                  <a:srgbClr val="F7F3E8"/>
-                </a:solidFill>
-              </a:rPr>
-              <a:t>$25K</a:t>
-            </a:r>
-            <a:endParaRPr lang="en-US" sz="3000" dirty="0"/>
+              <a:rPr lang="en-US" sz="2700" b="1" dirty="0">
+                <a:solidFill>
+                  <a:srgbClr val="FFFFFF"/>
+                </a:solidFill>
+              </a:rPr>
+              <a:t>$50K</a:t>
+            </a:r>
+            <a:endParaRPr lang="en-US" sz="2700" dirty="0"/>
           </a:p>
         </p:txBody>
       </p:sp>
@@ -3247,8 +2997,8 @@
         </p:nvSpPr>
         <p:spPr>
           <a:xfrm>
-            <a:off x="841248" y="4956048"/>
-            <a:ext cx="2286000" cy="320040"/>
+            <a:off x="1051560" y="4928616"/>
+            <a:ext cx="2359152" cy="256032"/>
           </a:xfrm>
           <a:prstGeom prst="rect">
             <a:avLst/>
@@ -3266,14 +3016,14 @@
               <a:buNone/>
             </a:pPr>
             <a:r>
-              <a:rPr lang="en-US" sz="1050" dirty="0">
-                <a:solidFill>
-                  <a:srgbClr val="AAA79D"/>
-                </a:solidFill>
-              </a:rPr>
-              <a:t>authorized from a $75K request</a:t>
-            </a:r>
-            <a:endParaRPr lang="en-US" sz="1050" dirty="0"/>
+              <a:rPr lang="en-US" sz="980" dirty="0">
+                <a:solidFill>
+                  <a:srgbClr val="DBEAFE"/>
+                </a:solidFill>
+              </a:rPr>
+              <a:t>capital controlled before payout</a:t>
+            </a:r>
+            <a:endParaRPr lang="en-US" sz="980" dirty="0"/>
           </a:p>
         </p:txBody>
       </p:sp>
@@ -3285,18 +3035,20 @@
         </p:nvSpPr>
         <p:spPr>
           <a:xfrm>
-            <a:off x="7022592" y="713232"/>
-            <a:ext cx="4434840" cy="5230368"/>
-          </a:xfrm>
-          <a:prstGeom prst="rect">
-            <a:avLst/>
+            <a:off x="6629400" y="932688"/>
+            <a:ext cx="4389120" cy="4553712"/>
+          </a:xfrm>
+          <a:prstGeom prst="roundRect">
+            <a:avLst>
+              <a:gd name="adj" fmla="val 4167"/>
+            </a:avLst>
           </a:prstGeom>
           <a:solidFill>
-            <a:srgbClr val="20231D"/>
+            <a:srgbClr val="FFFFFF"/>
           </a:solidFill>
           <a:ln w="12700">
             <a:solidFill>
-              <a:srgbClr val="3A3D32"/>
+              <a:srgbClr val="D8D2C4"/>
             </a:solidFill>
             <a:prstDash val="solid"/>
           </a:ln>
@@ -3310,8 +3062,8 @@
         </p:nvSpPr>
         <p:spPr>
           <a:xfrm>
-            <a:off x="7370064" y="1143000"/>
-            <a:ext cx="3703320" cy="4069080"/>
+            <a:off x="7022592" y="1426464"/>
+            <a:ext cx="3657600" cy="3520440"/>
           </a:xfrm>
           <a:prstGeom prst="rect">
             <a:avLst/>
@@ -3331,10 +3083,10 @@
             <a:r>
               <a:rPr lang="en-US" sz="1600" b="1" dirty="0">
                 <a:solidFill>
-                  <a:srgbClr val="F7F3E8"/>
-                </a:solidFill>
-              </a:rPr>
-              <a:t>• CLEAR: verified release</a:t>
+                  <a:srgbClr val="111827"/>
+                </a:solidFill>
+              </a:rPr>
+              <a:t>- requested: $75K</a:t>
             </a:r>
             <a:endParaRPr lang="en-US" sz="1600" dirty="0"/>
           </a:p>
@@ -3345,10 +3097,10 @@
             <a:r>
               <a:rPr lang="en-US" sz="1600" b="1" dirty="0">
                 <a:solidFill>
-                  <a:srgbClr val="F7F3E8"/>
-                </a:solidFill>
-              </a:rPr>
-              <a:t>• LIMIT: capped payout</a:t>
+                  <a:srgbClr val="111827"/>
+                </a:solidFill>
+              </a:rPr>
+              <a:t>- proof spend: $0.39</a:t>
             </a:r>
             <a:endParaRPr lang="en-US" sz="1600" dirty="0"/>
           </a:p>
@@ -3359,10 +3111,10 @@
             <a:r>
               <a:rPr lang="en-US" sz="1600" b="1" dirty="0">
                 <a:solidFill>
-                  <a:srgbClr val="F7F3E8"/>
-                </a:solidFill>
-              </a:rPr>
-              <a:t>• REVIEW: human queue</a:t>
+                  <a:srgbClr val="111827"/>
+                </a:solidFill>
+              </a:rPr>
+              <a:t>- approved: $25K</a:t>
             </a:r>
             <a:endParaRPr lang="en-US" sz="1600" dirty="0"/>
           </a:p>
@@ -3373,10 +3125,10 @@
             <a:r>
               <a:rPr lang="en-US" sz="1600" b="1" dirty="0">
                 <a:solidFill>
-                  <a:srgbClr val="F7F3E8"/>
-                </a:solidFill>
-              </a:rPr>
-              <a:t>• BLOCK: hard stop</a:t>
+                  <a:srgbClr val="111827"/>
+                </a:solidFill>
+              </a:rPr>
+              <a:t>- held: $50K</a:t>
             </a:r>
             <a:endParaRPr lang="en-US" sz="1600" dirty="0"/>
           </a:p>
@@ -3384,14 +3136,37 @@
       </p:sp>
       <p:sp>
         <p:nvSpPr>
-          <p:cNvPr id="11" name="Text 9"/>
-          <p:cNvSpPr/>
-          <p:nvPr/>
-        </p:nvSpPr>
-        <p:spPr>
-          <a:xfrm>
-            <a:off x="10643616" y="6236208"/>
-            <a:ext cx="685800" cy="164592"/>
+          <p:cNvPr id="11" name="Shape 9"/>
+          <p:cNvSpPr/>
+          <p:nvPr/>
+        </p:nvSpPr>
+        <p:spPr>
+          <a:xfrm>
+            <a:off x="6949440" y="5157216"/>
+            <a:ext cx="3520440" cy="0"/>
+          </a:xfrm>
+          <a:prstGeom prst="line">
+            <a:avLst/>
+          </a:prstGeom>
+          <a:noFill/>
+          <a:ln w="38100">
+            <a:solidFill>
+              <a:srgbClr val="36C78A"/>
+            </a:solidFill>
+            <a:prstDash val="solid"/>
+          </a:ln>
+        </p:spPr>
+      </p:sp>
+      <p:sp>
+        <p:nvSpPr>
+          <p:cNvPr id="12" name="Text 10"/>
+          <p:cNvSpPr/>
+          <p:nvPr/>
+        </p:nvSpPr>
+        <p:spPr>
+          <a:xfrm>
+            <a:off x="10378440" y="6080760"/>
+            <a:ext cx="438912" cy="164592"/>
           </a:xfrm>
           <a:prstGeom prst="rect">
             <a:avLst/>
@@ -3407,14 +3182,14 @@
               <a:buNone/>
             </a:pPr>
             <a:r>
-              <a:rPr lang="en-US" sz="900" dirty="0">
-                <a:solidFill>
-                  <a:srgbClr val="C9B98B"/>
+              <a:rPr lang="en-US" sz="800" dirty="0">
+                <a:solidFill>
+                  <a:srgbClr val="64748B"/>
                 </a:solidFill>
               </a:rPr>
               <a:t>5 / 7</a:t>
             </a:r>
-            <a:endParaRPr lang="en-US" sz="900" dirty="0"/>
+            <a:endParaRPr lang="en-US" sz="800" dirty="0"/>
           </a:p>
         </p:txBody>
       </p:sp>
@@ -3432,7 +3207,7 @@
     <p:bg>
       <p:bgPr>
         <a:solidFill>
-          <a:srgbClr val="0B0C0A"/>
+          <a:srgbClr val="F7F2E8"/>
         </a:solidFill>
       </p:bgPr>
     </p:bg>
@@ -3458,18 +3233,20 @@
         </p:nvSpPr>
         <p:spPr>
           <a:xfrm>
-            <a:off x="256032" y="256032"/>
-            <a:ext cx="11686032" cy="6355080"/>
-          </a:xfrm>
-          <a:prstGeom prst="rect">
-            <a:avLst/>
+            <a:off x="411480" y="411480"/>
+            <a:ext cx="11365992" cy="6035040"/>
+          </a:xfrm>
+          <a:prstGeom prst="rect">
+            <a:avLst>
+              <a:gd name="adj" fmla="val 2727"/>
+            </a:avLst>
           </a:prstGeom>
           <a:solidFill>
-            <a:srgbClr val="12140F"/>
+            <a:srgbClr val="FFFBF2"/>
           </a:solidFill>
           <a:ln w="12700">
             <a:solidFill>
-              <a:srgbClr val="3A3D32"/>
+              <a:srgbClr val="D8D2C4"/>
             </a:solidFill>
             <a:prstDash val="solid"/>
           </a:ln>
@@ -3483,8 +3260,8 @@
         </p:nvSpPr>
         <p:spPr>
           <a:xfrm>
-            <a:off x="566928" y="621792"/>
-            <a:ext cx="2926080" cy="237744"/>
+            <a:off x="786384" y="777240"/>
+            <a:ext cx="4206240" cy="228600"/>
           </a:xfrm>
           <a:prstGeom prst="rect">
             <a:avLst/>
@@ -3502,10 +3279,10 @@
             <a:r>
               <a:rPr lang="en-US" sz="1000" b="1" dirty="0">
                 <a:solidFill>
-                  <a:srgbClr val="C9B98B"/>
-                </a:solidFill>
-              </a:rPr>
-              <a:t>06 / VERIFICATION</a:t>
+                  <a:srgbClr val="245BFF"/>
+                </a:solidFill>
+              </a:rPr>
+              <a:t>06 / VERIFIABLE LEDGER</a:t>
             </a:r>
             <a:endParaRPr lang="en-US" sz="1000" dirty="0"/>
           </a:p>
@@ -3519,8 +3296,8 @@
         </p:nvSpPr>
         <p:spPr>
           <a:xfrm>
-            <a:off x="566928" y="960120"/>
-            <a:ext cx="6080760" cy="1508760"/>
+            <a:off x="786384" y="1115568"/>
+            <a:ext cx="5577840" cy="1234440"/>
           </a:xfrm>
           <a:prstGeom prst="rect">
             <a:avLst/>
@@ -3538,14 +3315,14 @@
               <a:buNone/>
             </a:pPr>
             <a:r>
-              <a:rPr lang="en-US" sz="3100" b="1" dirty="0">
-                <a:solidFill>
-                  <a:srgbClr val="F7F3E8"/>
-                </a:solidFill>
-              </a:rPr>
-              <a:t>Every clearance becomes independently verifiable.</a:t>
-            </a:r>
-            <a:endParaRPr lang="en-US" sz="3100" dirty="0"/>
+              <a:rPr lang="en-US" sz="3000" b="1" dirty="0">
+                <a:solidFill>
+                  <a:srgbClr val="111827"/>
+                </a:solidFill>
+              </a:rPr>
+              <a:t>Every decision becomes a public verification object.</a:t>
+            </a:r>
+            <a:endParaRPr lang="en-US" sz="3000" dirty="0"/>
           </a:p>
         </p:txBody>
       </p:sp>
@@ -3557,8 +3334,8 @@
         </p:nvSpPr>
         <p:spPr>
           <a:xfrm>
-            <a:off x="594360" y="2615184"/>
-            <a:ext cx="5650992" cy="1097280"/>
+            <a:off x="804672" y="2596896"/>
+            <a:ext cx="5257800" cy="960120"/>
           </a:xfrm>
           <a:prstGeom prst="rect">
             <a:avLst/>
@@ -3576,14 +3353,14 @@
               <a:buNone/>
             </a:pPr>
             <a:r>
-              <a:rPr lang="en-US" sz="1500" dirty="0">
-                <a:solidFill>
-                  <a:srgbClr val="AAA79D"/>
-                </a:solidFill>
-              </a:rPr>
-              <a:t>The ClearancePacket contains proof hashes, policy version, expiry, rationale, public key, and signature. The ledger chains every event hash.</a:t>
-            </a:r>
-            <a:endParaRPr lang="en-US" sz="1500" dirty="0"/>
+              <a:rPr lang="en-US" sz="1400" dirty="0">
+                <a:solidFill>
+                  <a:srgbClr val="334155"/>
+                </a:solidFill>
+              </a:rPr>
+              <a:t>The ClearancePacket carries proof hashes, policy version, expiry, rationale, public key, and signature. The Vultr Postgres ledger chains every event hash.</a:t>
+            </a:r>
+            <a:endParaRPr lang="en-US" sz="1400" dirty="0"/>
           </a:p>
         </p:txBody>
       </p:sp>
@@ -3595,18 +3372,20 @@
         </p:nvSpPr>
         <p:spPr>
           <a:xfrm>
-            <a:off x="603504" y="4251960"/>
-            <a:ext cx="2788920" cy="1298448"/>
-          </a:xfrm>
-          <a:prstGeom prst="rect">
-            <a:avLst/>
+            <a:off x="804672" y="4315968"/>
+            <a:ext cx="2971800" cy="1078992"/>
+          </a:xfrm>
+          <a:prstGeom prst="roundRect">
+            <a:avLst>
+              <a:gd name="adj" fmla="val 15254"/>
+            </a:avLst>
           </a:prstGeom>
           <a:solidFill>
-            <a:srgbClr val="18231B"/>
+            <a:srgbClr val="111827"/>
           </a:solidFill>
-          <a:ln w="16510">
+          <a:ln w="12700">
             <a:solidFill>
-              <a:srgbClr val="8BD8A8"/>
+              <a:srgbClr val="111827"/>
             </a:solidFill>
             <a:prstDash val="solid"/>
           </a:ln>
@@ -3620,8 +3399,8 @@
         </p:nvSpPr>
         <p:spPr>
           <a:xfrm>
-            <a:off x="841248" y="4434840"/>
-            <a:ext cx="2286000" cy="502920"/>
+            <a:off x="1051560" y="4489704"/>
+            <a:ext cx="2468880" cy="411480"/>
           </a:xfrm>
           <a:prstGeom prst="rect">
             <a:avLst/>
@@ -3639,14 +3418,14 @@
               <a:buNone/>
             </a:pPr>
             <a:r>
-              <a:rPr lang="en-US" sz="3000" b="1" dirty="0">
-                <a:solidFill>
-                  <a:srgbClr val="F7F3E8"/>
+              <a:rPr lang="en-US" sz="2700" b="1" dirty="0">
+                <a:solidFill>
+                  <a:srgbClr val="FFFFFF"/>
                 </a:solidFill>
               </a:rPr>
               <a:t>valid</a:t>
             </a:r>
-            <a:endParaRPr lang="en-US" sz="3000" dirty="0"/>
+            <a:endParaRPr lang="en-US" sz="2700" dirty="0"/>
           </a:p>
         </p:txBody>
       </p:sp>
@@ -3658,8 +3437,8 @@
         </p:nvSpPr>
         <p:spPr>
           <a:xfrm>
-            <a:off x="841248" y="4956048"/>
-            <a:ext cx="2286000" cy="320040"/>
+            <a:off x="1051560" y="4928616"/>
+            <a:ext cx="2359152" cy="256032"/>
           </a:xfrm>
           <a:prstGeom prst="rect">
             <a:avLst/>
@@ -3677,14 +3456,14 @@
               <a:buNone/>
             </a:pPr>
             <a:r>
-              <a:rPr lang="en-US" sz="1050" dirty="0">
-                <a:solidFill>
-                  <a:srgbClr val="AAA79D"/>
+              <a:rPr lang="en-US" sz="980" dirty="0">
+                <a:solidFill>
+                  <a:srgbClr val="DBEAFE"/>
                 </a:solidFill>
               </a:rPr>
               <a:t>packet signature and event chain</a:t>
             </a:r>
-            <a:endParaRPr lang="en-US" sz="1050" dirty="0"/>
+            <a:endParaRPr lang="en-US" sz="980" dirty="0"/>
           </a:p>
         </p:txBody>
       </p:sp>
@@ -3696,18 +3475,20 @@
         </p:nvSpPr>
         <p:spPr>
           <a:xfrm>
-            <a:off x="7022592" y="713232"/>
-            <a:ext cx="4434840" cy="5230368"/>
-          </a:xfrm>
-          <a:prstGeom prst="rect">
-            <a:avLst/>
+            <a:off x="6629400" y="932688"/>
+            <a:ext cx="4389120" cy="4553712"/>
+          </a:xfrm>
+          <a:prstGeom prst="roundRect">
+            <a:avLst>
+              <a:gd name="adj" fmla="val 4167"/>
+            </a:avLst>
           </a:prstGeom>
           <a:solidFill>
-            <a:srgbClr val="20231D"/>
+            <a:srgbClr val="FFFFFF"/>
           </a:solidFill>
           <a:ln w="12700">
             <a:solidFill>
-              <a:srgbClr val="3A3D32"/>
+              <a:srgbClr val="D8D2C4"/>
             </a:solidFill>
             <a:prstDash val="solid"/>
           </a:ln>
@@ -3721,8 +3502,8 @@
         </p:nvSpPr>
         <p:spPr>
           <a:xfrm>
-            <a:off x="7370064" y="1143000"/>
-            <a:ext cx="3703320" cy="4069080"/>
+            <a:off x="7022592" y="1426464"/>
+            <a:ext cx="3657600" cy="3520440"/>
           </a:xfrm>
           <a:prstGeom prst="rect">
             <a:avLst/>
@@ -3742,10 +3523,10 @@
             <a:r>
               <a:rPr lang="en-US" sz="1600" b="1" dirty="0">
                 <a:solidFill>
-                  <a:srgbClr val="F7F3E8"/>
-                </a:solidFill>
-              </a:rPr>
-              <a:t>• production-key signature</a:t>
+                  <a:srgbClr val="111827"/>
+                </a:solidFill>
+              </a:rPr>
+              <a:t>- production-key signing mode</a:t>
             </a:r>
             <a:endParaRPr lang="en-US" sz="1600" dirty="0"/>
           </a:p>
@@ -3756,10 +3537,10 @@
             <a:r>
               <a:rPr lang="en-US" sz="1600" b="1" dirty="0">
                 <a:solidFill>
-                  <a:srgbClr val="F7F3E8"/>
-                </a:solidFill>
-              </a:rPr>
-              <a:t>• append-only event hashes</a:t>
+                  <a:srgbClr val="111827"/>
+                </a:solidFill>
+              </a:rPr>
+              <a:t>- append-only event hashes</a:t>
             </a:r>
             <a:endParaRPr lang="en-US" sz="1600" dirty="0"/>
           </a:p>
@@ -3770,10 +3551,10 @@
             <a:r>
               <a:rPr lang="en-US" sz="1600" b="1" dirty="0">
                 <a:solidFill>
-                  <a:srgbClr val="F7F3E8"/>
-                </a:solidFill>
-              </a:rPr>
-              <a:t>• /api/clearance/:id/verify</a:t>
+                  <a:srgbClr val="111827"/>
+                </a:solidFill>
+              </a:rPr>
+              <a:t>- /api/clearance/:id/verify</a:t>
             </a:r>
             <a:endParaRPr lang="en-US" sz="1600" dirty="0"/>
           </a:p>
@@ -3781,14 +3562,37 @@
       </p:sp>
       <p:sp>
         <p:nvSpPr>
-          <p:cNvPr id="11" name="Text 9"/>
-          <p:cNvSpPr/>
-          <p:nvPr/>
-        </p:nvSpPr>
-        <p:spPr>
-          <a:xfrm>
-            <a:off x="10643616" y="6236208"/>
-            <a:ext cx="685800" cy="164592"/>
+          <p:cNvPr id="11" name="Shape 9"/>
+          <p:cNvSpPr/>
+          <p:nvPr/>
+        </p:nvSpPr>
+        <p:spPr>
+          <a:xfrm>
+            <a:off x="6949440" y="5157216"/>
+            <a:ext cx="3520440" cy="0"/>
+          </a:xfrm>
+          <a:prstGeom prst="line">
+            <a:avLst/>
+          </a:prstGeom>
+          <a:noFill/>
+          <a:ln w="38100">
+            <a:solidFill>
+              <a:srgbClr val="245BFF"/>
+            </a:solidFill>
+            <a:prstDash val="solid"/>
+          </a:ln>
+        </p:spPr>
+      </p:sp>
+      <p:sp>
+        <p:nvSpPr>
+          <p:cNvPr id="12" name="Text 10"/>
+          <p:cNvSpPr/>
+          <p:nvPr/>
+        </p:nvSpPr>
+        <p:spPr>
+          <a:xfrm>
+            <a:off x="10378440" y="6080760"/>
+            <a:ext cx="438912" cy="164592"/>
           </a:xfrm>
           <a:prstGeom prst="rect">
             <a:avLst/>
@@ -3804,14 +3608,14 @@
               <a:buNone/>
             </a:pPr>
             <a:r>
-              <a:rPr lang="en-US" sz="900" dirty="0">
-                <a:solidFill>
-                  <a:srgbClr val="C9B98B"/>
+              <a:rPr lang="en-US" sz="800" dirty="0">
+                <a:solidFill>
+                  <a:srgbClr val="64748B"/>
                 </a:solidFill>
               </a:rPr>
               <a:t>6 / 7</a:t>
             </a:r>
-            <a:endParaRPr lang="en-US" sz="900" dirty="0"/>
+            <a:endParaRPr lang="en-US" sz="800" dirty="0"/>
           </a:p>
         </p:txBody>
       </p:sp>
@@ -3829,7 +3633,7 @@
     <p:bg>
       <p:bgPr>
         <a:solidFill>
-          <a:srgbClr val="0B0C0A"/>
+          <a:srgbClr val="F7F2E8"/>
         </a:solidFill>
       </p:bgPr>
     </p:bg>
@@ -3855,18 +3659,20 @@
         </p:nvSpPr>
         <p:spPr>
           <a:xfrm>
-            <a:off x="256032" y="256032"/>
-            <a:ext cx="11686032" cy="6355080"/>
-          </a:xfrm>
-          <a:prstGeom prst="rect">
-            <a:avLst/>
+            <a:off x="411480" y="411480"/>
+            <a:ext cx="11365992" cy="6035040"/>
+          </a:xfrm>
+          <a:prstGeom prst="rect">
+            <a:avLst>
+              <a:gd name="adj" fmla="val 2727"/>
+            </a:avLst>
           </a:prstGeom>
           <a:solidFill>
-            <a:srgbClr val="12140F"/>
+            <a:srgbClr val="FFFBF2"/>
           </a:solidFill>
           <a:ln w="12700">
             <a:solidFill>
-              <a:srgbClr val="3A3D32"/>
+              <a:srgbClr val="D8D2C4"/>
             </a:solidFill>
             <a:prstDash val="solid"/>
           </a:ln>
@@ -3880,8 +3686,8 @@
         </p:nvSpPr>
         <p:spPr>
           <a:xfrm>
-            <a:off x="566928" y="621792"/>
-            <a:ext cx="2926080" cy="237744"/>
+            <a:off x="786384" y="777240"/>
+            <a:ext cx="4206240" cy="228600"/>
           </a:xfrm>
           <a:prstGeom prst="rect">
             <a:avLst/>
@@ -3899,7 +3705,7 @@
             <a:r>
               <a:rPr lang="en-US" sz="1000" b="1" dirty="0">
                 <a:solidFill>
-                  <a:srgbClr val="C9B98B"/>
+                  <a:srgbClr val="6D4AFF"/>
                 </a:solidFill>
               </a:rPr>
               <a:t>07 / WHY IT WINS</a:t>
@@ -3916,8 +3722,8 @@
         </p:nvSpPr>
         <p:spPr>
           <a:xfrm>
-            <a:off x="566928" y="960120"/>
-            <a:ext cx="6080760" cy="1508760"/>
+            <a:off x="786384" y="1115568"/>
+            <a:ext cx="5577840" cy="1234440"/>
           </a:xfrm>
           <a:prstGeom prst="rect">
             <a:avLst/>
@@ -3935,14 +3741,14 @@
               <a:buNone/>
             </a:pPr>
             <a:r>
-              <a:rPr lang="en-US" sz="3100" b="1" dirty="0">
-                <a:solidFill>
-                  <a:srgbClr val="F7F3E8"/>
-                </a:solidFill>
-              </a:rPr>
-              <a:t>A protocol-shaped product for autonomous finance.</a:t>
-            </a:r>
-            <a:endParaRPr lang="en-US" sz="3100" dirty="0"/>
+              <a:rPr lang="en-US" sz="3000" b="1" dirty="0">
+                <a:solidFill>
+                  <a:srgbClr val="111827"/>
+                </a:solidFill>
+              </a:rPr>
+              <a:t>A payment primitive for agentic finance, not a generic dashboard.</a:t>
+            </a:r>
+            <a:endParaRPr lang="en-US" sz="3000" dirty="0"/>
           </a:p>
         </p:txBody>
       </p:sp>
@@ -3954,8 +3760,8 @@
         </p:nvSpPr>
         <p:spPr>
           <a:xfrm>
-            <a:off x="594360" y="2615184"/>
-            <a:ext cx="5650992" cy="1097280"/>
+            <a:off x="804672" y="2596896"/>
+            <a:ext cx="5257800" cy="960120"/>
           </a:xfrm>
           <a:prstGeom prst="rect">
             <a:avLst/>
@@ -3973,14 +3779,14 @@
               <a:buNone/>
             </a:pPr>
             <a:r>
-              <a:rPr lang="en-US" sz="1500" dirty="0">
-                <a:solidFill>
-                  <a:srgbClr val="AAA79D"/>
-                </a:solidFill>
-              </a:rPr>
-              <a:t>DisburseGuard aligns directly with x402 payments, Gemini, Vultr, B2B FinOps, compliance, and agentic workflows.</a:t>
-            </a:r>
-            <a:endParaRPr lang="en-US" sz="1500" dirty="0"/>
+              <a:rPr lang="en-US" sz="1400" dirty="0">
+                <a:solidFill>
+                  <a:srgbClr val="334155"/>
+                </a:solidFill>
+              </a:rPr>
+              <a:t>DisburseGuard aligns the strongest hackathon surfaces: x402 paid proof gates, Gemini extraction, Vultr deployment, B2B FinOps, compliance, and a multi-step agent workflow.</a:t>
+            </a:r>
+            <a:endParaRPr lang="en-US" sz="1400" dirty="0"/>
           </a:p>
         </p:txBody>
       </p:sp>
@@ -3992,18 +3798,20 @@
         </p:nvSpPr>
         <p:spPr>
           <a:xfrm>
-            <a:off x="603504" y="4251960"/>
-            <a:ext cx="2788920" cy="1298448"/>
-          </a:xfrm>
-          <a:prstGeom prst="rect">
-            <a:avLst/>
+            <a:off x="804672" y="4315968"/>
+            <a:ext cx="2971800" cy="1078992"/>
+          </a:xfrm>
+          <a:prstGeom prst="roundRect">
+            <a:avLst>
+              <a:gd name="adj" fmla="val 15254"/>
+            </a:avLst>
           </a:prstGeom>
           <a:solidFill>
-            <a:srgbClr val="18231B"/>
+            <a:srgbClr val="111827"/>
           </a:solidFill>
-          <a:ln w="16510">
+          <a:ln w="12700">
             <a:solidFill>
-              <a:srgbClr val="8BD8A8"/>
+              <a:srgbClr val="111827"/>
             </a:solidFill>
             <a:prstDash val="solid"/>
           </a:ln>
@@ -4017,8 +3825,8 @@
         </p:nvSpPr>
         <p:spPr>
           <a:xfrm>
-            <a:off x="841248" y="4434840"/>
-            <a:ext cx="2286000" cy="502920"/>
+            <a:off x="1051560" y="4489704"/>
+            <a:ext cx="2468880" cy="411480"/>
           </a:xfrm>
           <a:prstGeom prst="rect">
             <a:avLst/>
@@ -4036,14 +3844,14 @@
               <a:buNone/>
             </a:pPr>
             <a:r>
-              <a:rPr lang="en-US" sz="3000" b="1" dirty="0">
-                <a:solidFill>
-                  <a:srgbClr val="F7F3E8"/>
+              <a:rPr lang="en-US" sz="2700" b="1" dirty="0">
+                <a:solidFill>
+                  <a:srgbClr val="FFFFFF"/>
                 </a:solidFill>
               </a:rPr>
               <a:t>live</a:t>
             </a:r>
-            <a:endParaRPr lang="en-US" sz="3000" dirty="0"/>
+            <a:endParaRPr lang="en-US" sz="2700" dirty="0"/>
           </a:p>
         </p:txBody>
       </p:sp>
@@ -4055,8 +3863,8 @@
         </p:nvSpPr>
         <p:spPr>
           <a:xfrm>
-            <a:off x="841248" y="4956048"/>
-            <a:ext cx="2286000" cy="320040"/>
+            <a:off x="1051560" y="4928616"/>
+            <a:ext cx="2359152" cy="256032"/>
           </a:xfrm>
           <a:prstGeom prst="rect">
             <a:avLst/>
@@ -4074,14 +3882,14 @@
               <a:buNone/>
             </a:pPr>
             <a:r>
-              <a:rPr lang="en-US" sz="1050" dirty="0">
-                <a:solidFill>
-                  <a:srgbClr val="AAA79D"/>
+              <a:rPr lang="en-US" sz="980" dirty="0">
+                <a:solidFill>
+                  <a:srgbClr val="DBEAFE"/>
                 </a:solidFill>
               </a:rPr>
               <a:t>public Vultr deployment</a:t>
             </a:r>
-            <a:endParaRPr lang="en-US" sz="1050" dirty="0"/>
+            <a:endParaRPr lang="en-US" sz="980" dirty="0"/>
           </a:p>
         </p:txBody>
       </p:sp>
@@ -4093,18 +3901,20 @@
         </p:nvSpPr>
         <p:spPr>
           <a:xfrm>
-            <a:off x="7022592" y="713232"/>
-            <a:ext cx="4434840" cy="5230368"/>
-          </a:xfrm>
-          <a:prstGeom prst="rect">
-            <a:avLst/>
+            <a:off x="6629400" y="932688"/>
+            <a:ext cx="4389120" cy="4553712"/>
+          </a:xfrm>
+          <a:prstGeom prst="roundRect">
+            <a:avLst>
+              <a:gd name="adj" fmla="val 4167"/>
+            </a:avLst>
           </a:prstGeom>
           <a:solidFill>
-            <a:srgbClr val="20231D"/>
+            <a:srgbClr val="FFFFFF"/>
           </a:solidFill>
           <a:ln w="12700">
             <a:solidFill>
-              <a:srgbClr val="3A3D32"/>
+              <a:srgbClr val="D8D2C4"/>
             </a:solidFill>
             <a:prstDash val="solid"/>
           </a:ln>
@@ -4118,8 +3928,8 @@
         </p:nvSpPr>
         <p:spPr>
           <a:xfrm>
-            <a:off x="7370064" y="1143000"/>
-            <a:ext cx="3703320" cy="4069080"/>
+            <a:off x="7022592" y="1426464"/>
+            <a:ext cx="3657600" cy="3520440"/>
           </a:xfrm>
           <a:prstGeom prst="rect">
             <a:avLst/>
@@ -4139,10 +3949,10 @@
             <a:r>
               <a:rPr lang="en-US" sz="1600" b="1" dirty="0">
                 <a:solidFill>
-                  <a:srgbClr val="F7F3E8"/>
-                </a:solidFill>
-              </a:rPr>
-              <a:t>• x402: paid proof primitive</a:t>
+                  <a:srgbClr val="111827"/>
+                </a:solidFill>
+              </a:rPr>
+              <a:t>- x402: proof purchase primitive</a:t>
             </a:r>
             <a:endParaRPr lang="en-US" sz="1600" dirty="0"/>
           </a:p>
@@ -4153,10 +3963,10 @@
             <a:r>
               <a:rPr lang="en-US" sz="1600" b="1" dirty="0">
                 <a:solidFill>
-                  <a:srgbClr val="F7F3E8"/>
-                </a:solidFill>
-              </a:rPr>
-              <a:t>• Gemini: extraction agent</a:t>
+                  <a:srgbClr val="111827"/>
+                </a:solidFill>
+              </a:rPr>
+              <a:t>- Gemini: structured intake</a:t>
             </a:r>
             <a:endParaRPr lang="en-US" sz="1600" dirty="0"/>
           </a:p>
@@ -4167,10 +3977,10 @@
             <a:r>
               <a:rPr lang="en-US" sz="1600" b="1" dirty="0">
                 <a:solidFill>
-                  <a:srgbClr val="F7F3E8"/>
-                </a:solidFill>
-              </a:rPr>
-              <a:t>• Vultr: deployed ledger</a:t>
+                  <a:srgbClr val="111827"/>
+                </a:solidFill>
+              </a:rPr>
+              <a:t>- Vultr: deployed ledger</a:t>
             </a:r>
             <a:endParaRPr lang="en-US" sz="1600" dirty="0"/>
           </a:p>
@@ -4181,10 +3991,10 @@
             <a:r>
               <a:rPr lang="en-US" sz="1600" b="1" dirty="0">
                 <a:solidFill>
-                  <a:srgbClr val="F7F3E8"/>
-                </a:solidFill>
-              </a:rPr>
-              <a:t>• FinOps: payout control</a:t>
+                  <a:srgbClr val="111827"/>
+                </a:solidFill>
+              </a:rPr>
+              <a:t>- FinOps: payout control</a:t>
             </a:r>
             <a:endParaRPr lang="en-US" sz="1600" dirty="0"/>
           </a:p>
@@ -4192,14 +4002,37 @@
       </p:sp>
       <p:sp>
         <p:nvSpPr>
-          <p:cNvPr id="11" name="Text 9"/>
-          <p:cNvSpPr/>
-          <p:nvPr/>
-        </p:nvSpPr>
-        <p:spPr>
-          <a:xfrm>
-            <a:off x="10643616" y="6236208"/>
-            <a:ext cx="685800" cy="164592"/>
+          <p:cNvPr id="11" name="Shape 9"/>
+          <p:cNvSpPr/>
+          <p:nvPr/>
+        </p:nvSpPr>
+        <p:spPr>
+          <a:xfrm>
+            <a:off x="6949440" y="5157216"/>
+            <a:ext cx="3520440" cy="0"/>
+          </a:xfrm>
+          <a:prstGeom prst="line">
+            <a:avLst/>
+          </a:prstGeom>
+          <a:noFill/>
+          <a:ln w="38100">
+            <a:solidFill>
+              <a:srgbClr val="6D4AFF"/>
+            </a:solidFill>
+            <a:prstDash val="solid"/>
+          </a:ln>
+        </p:spPr>
+      </p:sp>
+      <p:sp>
+        <p:nvSpPr>
+          <p:cNvPr id="12" name="Text 10"/>
+          <p:cNvSpPr/>
+          <p:nvPr/>
+        </p:nvSpPr>
+        <p:spPr>
+          <a:xfrm>
+            <a:off x="10378440" y="6080760"/>
+            <a:ext cx="438912" cy="164592"/>
           </a:xfrm>
           <a:prstGeom prst="rect">
             <a:avLst/>
@@ -4215,14 +4048,14 @@
               <a:buNone/>
             </a:pPr>
             <a:r>
-              <a:rPr lang="en-US" sz="900" dirty="0">
-                <a:solidFill>
-                  <a:srgbClr val="C9B98B"/>
+              <a:rPr lang="en-US" sz="800" dirty="0">
+                <a:solidFill>
+                  <a:srgbClr val="64748B"/>
                 </a:solidFill>
               </a:rPr>
               <a:t>7 / 7</a:t>
             </a:r>
-            <a:endParaRPr lang="en-US" sz="900" dirty="0"/>
+            <a:endParaRPr lang="en-US" sz="800" dirty="0"/>
           </a:p>
         </p:txBody>
       </p:sp>

</xml_diff>